<commit_message>
feat: add Demander une demo modal, SEO updates, commercial user setup
</commit_message>
<xml_diff>
--- a/playbook_cvc_gainable_v2.pptx
+++ b/playbook_cvc_gainable_v2.pptx
@@ -5,25 +5,25 @@
     <p:sldMasterId id="2147483648" r:id="rId1"/>
   </p:sldMasterIdLst>
   <p:sldIdLst>
-    <p:sldId id="256" r:id="rId7"/>
-    <p:sldId id="257" r:id="rId8"/>
-    <p:sldId id="258" r:id="rId9"/>
-    <p:sldId id="259" r:id="rId10"/>
-    <p:sldId id="260" r:id="rId11"/>
-    <p:sldId id="261" r:id="rId12"/>
-    <p:sldId id="262" r:id="rId13"/>
-    <p:sldId id="263" r:id="rId14"/>
-    <p:sldId id="264" r:id="rId15"/>
-    <p:sldId id="265" r:id="rId16"/>
-    <p:sldId id="266" r:id="rId17"/>
-    <p:sldId id="267" r:id="rId18"/>
-    <p:sldId id="268" r:id="rId19"/>
-    <p:sldId id="269" r:id="rId20"/>
-    <p:sldId id="270" r:id="rId21"/>
-    <p:sldId id="271" r:id="rId22"/>
-    <p:sldId id="272" r:id="rId23"/>
+    <p:sldId id="256" r:id="rId2"/>
+    <p:sldId id="257" r:id="rId3"/>
+    <p:sldId id="258" r:id="rId4"/>
+    <p:sldId id="259" r:id="rId5"/>
+    <p:sldId id="260" r:id="rId6"/>
+    <p:sldId id="261" r:id="rId7"/>
+    <p:sldId id="262" r:id="rId8"/>
+    <p:sldId id="263" r:id="rId9"/>
+    <p:sldId id="264" r:id="rId10"/>
+    <p:sldId id="265" r:id="rId11"/>
+    <p:sldId id="266" r:id="rId12"/>
+    <p:sldId id="267" r:id="rId13"/>
+    <p:sldId id="268" r:id="rId14"/>
+    <p:sldId id="269" r:id="rId15"/>
+    <p:sldId id="270" r:id="rId16"/>
+    <p:sldId id="271" r:id="rId17"/>
+    <p:sldId id="272" r:id="rId18"/>
   </p:sldIdLst>
-  <p:sldSz cx="12191695" cy="6858000" type="screen4x3"/>
+  <p:sldSz cx="12192000" cy="6858000"/>
   <p:notesSz cx="6858000" cy="9144000"/>
   <p:defaultTextStyle>
     <a:defPPr>
@@ -120,6 +120,22 @@
       </a:defRPr>
     </a:lvl9pPr>
   </p:defaultTextStyle>
+  <p:extLst>
+    <p:ext uri="{EFAFB233-063F-42B5-8137-9DF3F51BA10A}">
+      <p15:sldGuideLst xmlns:p15="http://schemas.microsoft.com/office/powerpoint/2012/main">
+        <p15:guide id="1" orient="horz" pos="2160">
+          <p15:clr>
+            <a:srgbClr val="A4A3A4"/>
+          </p15:clr>
+        </p15:guide>
+        <p15:guide id="2" pos="2880">
+          <p15:clr>
+            <a:srgbClr val="A4A3A4"/>
+          </p15:clr>
+        </p15:guide>
+      </p15:sldGuideLst>
+    </p:ext>
+  </p:extLst>
 </p:presentation>
 </file>
 
@@ -161,10 +177,9 @@
           <a:lstStyle/>
           <a:p>
             <a:r>
-              <a:rPr lang="en-US" smtClean="0"/>
+              <a:rPr lang="en-US"/>
               <a:t>Click to edit Master title style</a:t>
             </a:r>
-            <a:endParaRPr lang="en-US"/>
           </a:p>
         </p:txBody>
       </p:sp>
@@ -280,10 +295,9 @@
           </a:lstStyle>
           <a:p>
             <a:r>
-              <a:rPr lang="en-US" smtClean="0"/>
+              <a:rPr lang="en-US"/>
               <a:t>Click to edit Master subtitle style</a:t>
             </a:r>
-            <a:endParaRPr lang="en-US"/>
           </a:p>
         </p:txBody>
       </p:sp>
@@ -304,7 +318,7 @@
           <a:p>
             <a:fld id="{5BCAD085-E8A6-8845-BD4E-CB4CCA059FC4}" type="datetimeFigureOut">
               <a:rPr lang="en-US" smtClean="0"/>
-              <a:t>1/27/13</a:t>
+              <a:t>6/25/2026</a:t>
             </a:fld>
             <a:endParaRPr lang="en-US"/>
           </a:p>
@@ -346,7 +360,7 @@
           <a:p>
             <a:fld id="{C1FF6DA9-008F-8B48-92A6-B652298478BF}" type="slidenum">
               <a:rPr lang="en-US" smtClean="0"/>
-              <a:t>‹#›</a:t>
+              <a:t>‹N°›</a:t>
             </a:fld>
             <a:endParaRPr lang="en-US"/>
           </a:p>
@@ -398,10 +412,9 @@
           <a:lstStyle/>
           <a:p>
             <a:r>
-              <a:rPr lang="en-US" smtClean="0"/>
+              <a:rPr lang="en-US"/>
               <a:t>Click to edit Master title style</a:t>
             </a:r>
-            <a:endParaRPr lang="en-US"/>
           </a:p>
         </p:txBody>
       </p:sp>
@@ -422,38 +435,37 @@
           <a:p>
             <a:pPr lvl="0"/>
             <a:r>
-              <a:rPr lang="en-US" smtClean="0"/>
+              <a:rPr lang="en-US"/>
               <a:t>Click to edit Master text styles</a:t>
             </a:r>
           </a:p>
           <a:p>
             <a:pPr lvl="1"/>
             <a:r>
-              <a:rPr lang="en-US" smtClean="0"/>
+              <a:rPr lang="en-US"/>
               <a:t>Second level</a:t>
             </a:r>
           </a:p>
           <a:p>
             <a:pPr lvl="2"/>
             <a:r>
-              <a:rPr lang="en-US" smtClean="0"/>
+              <a:rPr lang="en-US"/>
               <a:t>Third level</a:t>
             </a:r>
           </a:p>
           <a:p>
             <a:pPr lvl="3"/>
             <a:r>
-              <a:rPr lang="en-US" smtClean="0"/>
+              <a:rPr lang="en-US"/>
               <a:t>Fourth level</a:t>
             </a:r>
           </a:p>
           <a:p>
             <a:pPr lvl="4"/>
             <a:r>
-              <a:rPr lang="en-US" smtClean="0"/>
+              <a:rPr lang="en-US"/>
               <a:t>Fifth level</a:t>
             </a:r>
-            <a:endParaRPr lang="en-US"/>
           </a:p>
         </p:txBody>
       </p:sp>
@@ -474,7 +486,7 @@
           <a:p>
             <a:fld id="{5BCAD085-E8A6-8845-BD4E-CB4CCA059FC4}" type="datetimeFigureOut">
               <a:rPr lang="en-US" smtClean="0"/>
-              <a:t>1/27/13</a:t>
+              <a:t>6/25/2026</a:t>
             </a:fld>
             <a:endParaRPr lang="en-US"/>
           </a:p>
@@ -516,7 +528,7 @@
           <a:p>
             <a:fld id="{C1FF6DA9-008F-8B48-92A6-B652298478BF}" type="slidenum">
               <a:rPr lang="en-US" smtClean="0"/>
-              <a:t>‹#›</a:t>
+              <a:t>‹N°›</a:t>
             </a:fld>
             <a:endParaRPr lang="en-US"/>
           </a:p>
@@ -573,10 +585,9 @@
           <a:lstStyle/>
           <a:p>
             <a:r>
-              <a:rPr lang="en-US" smtClean="0"/>
+              <a:rPr lang="en-US"/>
               <a:t>Click to edit Master title style</a:t>
             </a:r>
-            <a:endParaRPr lang="en-US"/>
           </a:p>
         </p:txBody>
       </p:sp>
@@ -602,38 +613,37 @@
           <a:p>
             <a:pPr lvl="0"/>
             <a:r>
-              <a:rPr lang="en-US" smtClean="0"/>
+              <a:rPr lang="en-US"/>
               <a:t>Click to edit Master text styles</a:t>
             </a:r>
           </a:p>
           <a:p>
             <a:pPr lvl="1"/>
             <a:r>
-              <a:rPr lang="en-US" smtClean="0"/>
+              <a:rPr lang="en-US"/>
               <a:t>Second level</a:t>
             </a:r>
           </a:p>
           <a:p>
             <a:pPr lvl="2"/>
             <a:r>
-              <a:rPr lang="en-US" smtClean="0"/>
+              <a:rPr lang="en-US"/>
               <a:t>Third level</a:t>
             </a:r>
           </a:p>
           <a:p>
             <a:pPr lvl="3"/>
             <a:r>
-              <a:rPr lang="en-US" smtClean="0"/>
+              <a:rPr lang="en-US"/>
               <a:t>Fourth level</a:t>
             </a:r>
           </a:p>
           <a:p>
             <a:pPr lvl="4"/>
             <a:r>
-              <a:rPr lang="en-US" smtClean="0"/>
+              <a:rPr lang="en-US"/>
               <a:t>Fifth level</a:t>
             </a:r>
-            <a:endParaRPr lang="en-US"/>
           </a:p>
         </p:txBody>
       </p:sp>
@@ -654,7 +664,7 @@
           <a:p>
             <a:fld id="{5BCAD085-E8A6-8845-BD4E-CB4CCA059FC4}" type="datetimeFigureOut">
               <a:rPr lang="en-US" smtClean="0"/>
-              <a:t>1/27/13</a:t>
+              <a:t>6/25/2026</a:t>
             </a:fld>
             <a:endParaRPr lang="en-US"/>
           </a:p>
@@ -696,7 +706,7 @@
           <a:p>
             <a:fld id="{C1FF6DA9-008F-8B48-92A6-B652298478BF}" type="slidenum">
               <a:rPr lang="en-US" smtClean="0"/>
-              <a:t>‹#›</a:t>
+              <a:t>‹N°›</a:t>
             </a:fld>
             <a:endParaRPr lang="en-US"/>
           </a:p>
@@ -748,10 +758,9 @@
           <a:lstStyle/>
           <a:p>
             <a:r>
-              <a:rPr lang="en-US" smtClean="0"/>
+              <a:rPr lang="en-US"/>
               <a:t>Click to edit Master title style</a:t>
             </a:r>
-            <a:endParaRPr lang="en-US"/>
           </a:p>
         </p:txBody>
       </p:sp>
@@ -772,38 +781,37 @@
           <a:p>
             <a:pPr lvl="0"/>
             <a:r>
-              <a:rPr lang="en-US" smtClean="0"/>
+              <a:rPr lang="en-US"/>
               <a:t>Click to edit Master text styles</a:t>
             </a:r>
           </a:p>
           <a:p>
             <a:pPr lvl="1"/>
             <a:r>
-              <a:rPr lang="en-US" smtClean="0"/>
+              <a:rPr lang="en-US"/>
               <a:t>Second level</a:t>
             </a:r>
           </a:p>
           <a:p>
             <a:pPr lvl="2"/>
             <a:r>
-              <a:rPr lang="en-US" smtClean="0"/>
+              <a:rPr lang="en-US"/>
               <a:t>Third level</a:t>
             </a:r>
           </a:p>
           <a:p>
             <a:pPr lvl="3"/>
             <a:r>
-              <a:rPr lang="en-US" smtClean="0"/>
+              <a:rPr lang="en-US"/>
               <a:t>Fourth level</a:t>
             </a:r>
           </a:p>
           <a:p>
             <a:pPr lvl="4"/>
             <a:r>
-              <a:rPr lang="en-US" smtClean="0"/>
+              <a:rPr lang="en-US"/>
               <a:t>Fifth level</a:t>
             </a:r>
-            <a:endParaRPr lang="en-US"/>
           </a:p>
         </p:txBody>
       </p:sp>
@@ -824,7 +832,7 @@
           <a:p>
             <a:fld id="{5BCAD085-E8A6-8845-BD4E-CB4CCA059FC4}" type="datetimeFigureOut">
               <a:rPr lang="en-US" smtClean="0"/>
-              <a:t>1/27/13</a:t>
+              <a:t>6/25/2026</a:t>
             </a:fld>
             <a:endParaRPr lang="en-US"/>
           </a:p>
@@ -866,7 +874,7 @@
           <a:p>
             <a:fld id="{C1FF6DA9-008F-8B48-92A6-B652298478BF}" type="slidenum">
               <a:rPr lang="en-US" smtClean="0"/>
-              <a:t>‹#›</a:t>
+              <a:t>‹N°›</a:t>
             </a:fld>
             <a:endParaRPr lang="en-US"/>
           </a:p>
@@ -927,10 +935,9 @@
           </a:lstStyle>
           <a:p>
             <a:r>
-              <a:rPr lang="en-US" smtClean="0"/>
+              <a:rPr lang="en-US"/>
               <a:t>Click to edit Master title style</a:t>
             </a:r>
-            <a:endParaRPr lang="en-US"/>
           </a:p>
         </p:txBody>
       </p:sp>
@@ -1047,7 +1054,7 @@
           <a:p>
             <a:pPr lvl="0"/>
             <a:r>
-              <a:rPr lang="en-US" smtClean="0"/>
+              <a:rPr lang="en-US"/>
               <a:t>Click to edit Master text styles</a:t>
             </a:r>
           </a:p>
@@ -1070,7 +1077,7 @@
           <a:p>
             <a:fld id="{5BCAD085-E8A6-8845-BD4E-CB4CCA059FC4}" type="datetimeFigureOut">
               <a:rPr lang="en-US" smtClean="0"/>
-              <a:t>1/27/13</a:t>
+              <a:t>6/25/2026</a:t>
             </a:fld>
             <a:endParaRPr lang="en-US"/>
           </a:p>
@@ -1112,7 +1119,7 @@
           <a:p>
             <a:fld id="{C1FF6DA9-008F-8B48-92A6-B652298478BF}" type="slidenum">
               <a:rPr lang="en-US" smtClean="0"/>
-              <a:t>‹#›</a:t>
+              <a:t>‹N°›</a:t>
             </a:fld>
             <a:endParaRPr lang="en-US"/>
           </a:p>
@@ -1164,10 +1171,9 @@
           <a:lstStyle/>
           <a:p>
             <a:r>
-              <a:rPr lang="en-US" smtClean="0"/>
+              <a:rPr lang="en-US"/>
               <a:t>Click to edit Master title style</a:t>
             </a:r>
-            <a:endParaRPr lang="en-US"/>
           </a:p>
         </p:txBody>
       </p:sp>
@@ -1221,38 +1227,37 @@
           <a:p>
             <a:pPr lvl="0"/>
             <a:r>
-              <a:rPr lang="en-US" smtClean="0"/>
+              <a:rPr lang="en-US"/>
               <a:t>Click to edit Master text styles</a:t>
             </a:r>
           </a:p>
           <a:p>
             <a:pPr lvl="1"/>
             <a:r>
-              <a:rPr lang="en-US" smtClean="0"/>
+              <a:rPr lang="en-US"/>
               <a:t>Second level</a:t>
             </a:r>
           </a:p>
           <a:p>
             <a:pPr lvl="2"/>
             <a:r>
-              <a:rPr lang="en-US" smtClean="0"/>
+              <a:rPr lang="en-US"/>
               <a:t>Third level</a:t>
             </a:r>
           </a:p>
           <a:p>
             <a:pPr lvl="3"/>
             <a:r>
-              <a:rPr lang="en-US" smtClean="0"/>
+              <a:rPr lang="en-US"/>
               <a:t>Fourth level</a:t>
             </a:r>
           </a:p>
           <a:p>
             <a:pPr lvl="4"/>
             <a:r>
-              <a:rPr lang="en-US" smtClean="0"/>
+              <a:rPr lang="en-US"/>
               <a:t>Fifth level</a:t>
             </a:r>
-            <a:endParaRPr lang="en-US"/>
           </a:p>
         </p:txBody>
       </p:sp>
@@ -1306,38 +1311,37 @@
           <a:p>
             <a:pPr lvl="0"/>
             <a:r>
-              <a:rPr lang="en-US" smtClean="0"/>
+              <a:rPr lang="en-US"/>
               <a:t>Click to edit Master text styles</a:t>
             </a:r>
           </a:p>
           <a:p>
             <a:pPr lvl="1"/>
             <a:r>
-              <a:rPr lang="en-US" smtClean="0"/>
+              <a:rPr lang="en-US"/>
               <a:t>Second level</a:t>
             </a:r>
           </a:p>
           <a:p>
             <a:pPr lvl="2"/>
             <a:r>
-              <a:rPr lang="en-US" smtClean="0"/>
+              <a:rPr lang="en-US"/>
               <a:t>Third level</a:t>
             </a:r>
           </a:p>
           <a:p>
             <a:pPr lvl="3"/>
             <a:r>
-              <a:rPr lang="en-US" smtClean="0"/>
+              <a:rPr lang="en-US"/>
               <a:t>Fourth level</a:t>
             </a:r>
           </a:p>
           <a:p>
             <a:pPr lvl="4"/>
             <a:r>
-              <a:rPr lang="en-US" smtClean="0"/>
+              <a:rPr lang="en-US"/>
               <a:t>Fifth level</a:t>
             </a:r>
-            <a:endParaRPr lang="en-US"/>
           </a:p>
         </p:txBody>
       </p:sp>
@@ -1358,7 +1362,7 @@
           <a:p>
             <a:fld id="{5BCAD085-E8A6-8845-BD4E-CB4CCA059FC4}" type="datetimeFigureOut">
               <a:rPr lang="en-US" smtClean="0"/>
-              <a:t>1/27/13</a:t>
+              <a:t>6/25/2026</a:t>
             </a:fld>
             <a:endParaRPr lang="en-US"/>
           </a:p>
@@ -1400,7 +1404,7 @@
           <a:p>
             <a:fld id="{C1FF6DA9-008F-8B48-92A6-B652298478BF}" type="slidenum">
               <a:rPr lang="en-US" smtClean="0"/>
-              <a:t>‹#›</a:t>
+              <a:t>‹N°›</a:t>
             </a:fld>
             <a:endParaRPr lang="en-US"/>
           </a:p>
@@ -1456,10 +1460,9 @@
           </a:lstStyle>
           <a:p>
             <a:r>
-              <a:rPr lang="en-US" smtClean="0"/>
+              <a:rPr lang="en-US"/>
               <a:t>Click to edit Master title style</a:t>
             </a:r>
-            <a:endParaRPr lang="en-US"/>
           </a:p>
         </p:txBody>
       </p:sp>
@@ -1522,7 +1525,7 @@
           <a:p>
             <a:pPr lvl="0"/>
             <a:r>
-              <a:rPr lang="en-US" smtClean="0"/>
+              <a:rPr lang="en-US"/>
               <a:t>Click to edit Master text styles</a:t>
             </a:r>
           </a:p>
@@ -1578,38 +1581,37 @@
           <a:p>
             <a:pPr lvl="0"/>
             <a:r>
-              <a:rPr lang="en-US" smtClean="0"/>
+              <a:rPr lang="en-US"/>
               <a:t>Click to edit Master text styles</a:t>
             </a:r>
           </a:p>
           <a:p>
             <a:pPr lvl="1"/>
             <a:r>
-              <a:rPr lang="en-US" smtClean="0"/>
+              <a:rPr lang="en-US"/>
               <a:t>Second level</a:t>
             </a:r>
           </a:p>
           <a:p>
             <a:pPr lvl="2"/>
             <a:r>
-              <a:rPr lang="en-US" smtClean="0"/>
+              <a:rPr lang="en-US"/>
               <a:t>Third level</a:t>
             </a:r>
           </a:p>
           <a:p>
             <a:pPr lvl="3"/>
             <a:r>
-              <a:rPr lang="en-US" smtClean="0"/>
+              <a:rPr lang="en-US"/>
               <a:t>Fourth level</a:t>
             </a:r>
           </a:p>
           <a:p>
             <a:pPr lvl="4"/>
             <a:r>
-              <a:rPr lang="en-US" smtClean="0"/>
+              <a:rPr lang="en-US"/>
               <a:t>Fifth level</a:t>
             </a:r>
-            <a:endParaRPr lang="en-US"/>
           </a:p>
         </p:txBody>
       </p:sp>
@@ -1672,7 +1674,7 @@
           <a:p>
             <a:pPr lvl="0"/>
             <a:r>
-              <a:rPr lang="en-US" smtClean="0"/>
+              <a:rPr lang="en-US"/>
               <a:t>Click to edit Master text styles</a:t>
             </a:r>
           </a:p>
@@ -1728,38 +1730,37 @@
           <a:p>
             <a:pPr lvl="0"/>
             <a:r>
-              <a:rPr lang="en-US" smtClean="0"/>
+              <a:rPr lang="en-US"/>
               <a:t>Click to edit Master text styles</a:t>
             </a:r>
           </a:p>
           <a:p>
             <a:pPr lvl="1"/>
             <a:r>
-              <a:rPr lang="en-US" smtClean="0"/>
+              <a:rPr lang="en-US"/>
               <a:t>Second level</a:t>
             </a:r>
           </a:p>
           <a:p>
             <a:pPr lvl="2"/>
             <a:r>
-              <a:rPr lang="en-US" smtClean="0"/>
+              <a:rPr lang="en-US"/>
               <a:t>Third level</a:t>
             </a:r>
           </a:p>
           <a:p>
             <a:pPr lvl="3"/>
             <a:r>
-              <a:rPr lang="en-US" smtClean="0"/>
+              <a:rPr lang="en-US"/>
               <a:t>Fourth level</a:t>
             </a:r>
           </a:p>
           <a:p>
             <a:pPr lvl="4"/>
             <a:r>
-              <a:rPr lang="en-US" smtClean="0"/>
+              <a:rPr lang="en-US"/>
               <a:t>Fifth level</a:t>
             </a:r>
-            <a:endParaRPr lang="en-US"/>
           </a:p>
         </p:txBody>
       </p:sp>
@@ -1780,7 +1781,7 @@
           <a:p>
             <a:fld id="{5BCAD085-E8A6-8845-BD4E-CB4CCA059FC4}" type="datetimeFigureOut">
               <a:rPr lang="en-US" smtClean="0"/>
-              <a:t>1/27/13</a:t>
+              <a:t>6/25/2026</a:t>
             </a:fld>
             <a:endParaRPr lang="en-US"/>
           </a:p>
@@ -1822,7 +1823,7 @@
           <a:p>
             <a:fld id="{C1FF6DA9-008F-8B48-92A6-B652298478BF}" type="slidenum">
               <a:rPr lang="en-US" smtClean="0"/>
-              <a:t>‹#›</a:t>
+              <a:t>‹N°›</a:t>
             </a:fld>
             <a:endParaRPr lang="en-US"/>
           </a:p>
@@ -1874,10 +1875,9 @@
           <a:lstStyle/>
           <a:p>
             <a:r>
-              <a:rPr lang="en-US" smtClean="0"/>
+              <a:rPr lang="en-US"/>
               <a:t>Click to edit Master title style</a:t>
             </a:r>
-            <a:endParaRPr lang="en-US"/>
           </a:p>
         </p:txBody>
       </p:sp>
@@ -1898,7 +1898,7 @@
           <a:p>
             <a:fld id="{5BCAD085-E8A6-8845-BD4E-CB4CCA059FC4}" type="datetimeFigureOut">
               <a:rPr lang="en-US" smtClean="0"/>
-              <a:t>1/27/13</a:t>
+              <a:t>6/25/2026</a:t>
             </a:fld>
             <a:endParaRPr lang="en-US"/>
           </a:p>
@@ -1940,7 +1940,7 @@
           <a:p>
             <a:fld id="{C1FF6DA9-008F-8B48-92A6-B652298478BF}" type="slidenum">
               <a:rPr lang="en-US" smtClean="0"/>
-              <a:t>‹#›</a:t>
+              <a:t>‹N°›</a:t>
             </a:fld>
             <a:endParaRPr lang="en-US"/>
           </a:p>
@@ -1993,7 +1993,7 @@
           <a:p>
             <a:fld id="{5BCAD085-E8A6-8845-BD4E-CB4CCA059FC4}" type="datetimeFigureOut">
               <a:rPr lang="en-US" smtClean="0"/>
-              <a:t>1/27/13</a:t>
+              <a:t>6/25/2026</a:t>
             </a:fld>
             <a:endParaRPr lang="en-US"/>
           </a:p>
@@ -2035,7 +2035,7 @@
           <a:p>
             <a:fld id="{C1FF6DA9-008F-8B48-92A6-B652298478BF}" type="slidenum">
               <a:rPr lang="en-US" smtClean="0"/>
-              <a:t>‹#›</a:t>
+              <a:t>‹N°›</a:t>
             </a:fld>
             <a:endParaRPr lang="en-US"/>
           </a:p>
@@ -2096,10 +2096,9 @@
           </a:lstStyle>
           <a:p>
             <a:r>
-              <a:rPr lang="en-US" smtClean="0"/>
+              <a:rPr lang="en-US"/>
               <a:t>Click to edit Master title style</a:t>
             </a:r>
-            <a:endParaRPr lang="en-US"/>
           </a:p>
         </p:txBody>
       </p:sp>
@@ -2153,38 +2152,37 @@
           <a:p>
             <a:pPr lvl="0"/>
             <a:r>
-              <a:rPr lang="en-US" smtClean="0"/>
+              <a:rPr lang="en-US"/>
               <a:t>Click to edit Master text styles</a:t>
             </a:r>
           </a:p>
           <a:p>
             <a:pPr lvl="1"/>
             <a:r>
-              <a:rPr lang="en-US" smtClean="0"/>
+              <a:rPr lang="en-US"/>
               <a:t>Second level</a:t>
             </a:r>
           </a:p>
           <a:p>
             <a:pPr lvl="2"/>
             <a:r>
-              <a:rPr lang="en-US" smtClean="0"/>
+              <a:rPr lang="en-US"/>
               <a:t>Third level</a:t>
             </a:r>
           </a:p>
           <a:p>
             <a:pPr lvl="3"/>
             <a:r>
-              <a:rPr lang="en-US" smtClean="0"/>
+              <a:rPr lang="en-US"/>
               <a:t>Fourth level</a:t>
             </a:r>
           </a:p>
           <a:p>
             <a:pPr lvl="4"/>
             <a:r>
-              <a:rPr lang="en-US" smtClean="0"/>
+              <a:rPr lang="en-US"/>
               <a:t>Fifth level</a:t>
             </a:r>
-            <a:endParaRPr lang="en-US"/>
           </a:p>
         </p:txBody>
       </p:sp>
@@ -2247,7 +2245,7 @@
           <a:p>
             <a:pPr lvl="0"/>
             <a:r>
-              <a:rPr lang="en-US" smtClean="0"/>
+              <a:rPr lang="en-US"/>
               <a:t>Click to edit Master text styles</a:t>
             </a:r>
           </a:p>
@@ -2270,7 +2268,7 @@
           <a:p>
             <a:fld id="{5BCAD085-E8A6-8845-BD4E-CB4CCA059FC4}" type="datetimeFigureOut">
               <a:rPr lang="en-US" smtClean="0"/>
-              <a:t>1/27/13</a:t>
+              <a:t>6/25/2026</a:t>
             </a:fld>
             <a:endParaRPr lang="en-US"/>
           </a:p>
@@ -2312,7 +2310,7 @@
           <a:p>
             <a:fld id="{C1FF6DA9-008F-8B48-92A6-B652298478BF}" type="slidenum">
               <a:rPr lang="en-US" smtClean="0"/>
-              <a:t>‹#›</a:t>
+              <a:t>‹N°›</a:t>
             </a:fld>
             <a:endParaRPr lang="en-US"/>
           </a:p>
@@ -2373,10 +2371,9 @@
           </a:lstStyle>
           <a:p>
             <a:r>
-              <a:rPr lang="en-US" smtClean="0"/>
+              <a:rPr lang="en-US"/>
               <a:t>Click to edit Master title style</a:t>
             </a:r>
-            <a:endParaRPr lang="en-US"/>
           </a:p>
         </p:txBody>
       </p:sp>
@@ -2500,7 +2497,7 @@
           <a:p>
             <a:pPr lvl="0"/>
             <a:r>
-              <a:rPr lang="en-US" smtClean="0"/>
+              <a:rPr lang="en-US"/>
               <a:t>Click to edit Master text styles</a:t>
             </a:r>
           </a:p>
@@ -2523,7 +2520,7 @@
           <a:p>
             <a:fld id="{5BCAD085-E8A6-8845-BD4E-CB4CCA059FC4}" type="datetimeFigureOut">
               <a:rPr lang="en-US" smtClean="0"/>
-              <a:t>1/27/13</a:t>
+              <a:t>6/25/2026</a:t>
             </a:fld>
             <a:endParaRPr lang="en-US"/>
           </a:p>
@@ -2565,7 +2562,7 @@
           <a:p>
             <a:fld id="{C1FF6DA9-008F-8B48-92A6-B652298478BF}" type="slidenum">
               <a:rPr lang="en-US" smtClean="0"/>
-              <a:t>‹#›</a:t>
+              <a:t>‹N°›</a:t>
             </a:fld>
             <a:endParaRPr lang="en-US"/>
           </a:p>
@@ -2632,10 +2629,9 @@
           <a:lstStyle/>
           <a:p>
             <a:r>
-              <a:rPr lang="en-US" smtClean="0"/>
+              <a:rPr lang="en-US"/>
               <a:t>Click to edit Master title style</a:t>
             </a:r>
-            <a:endParaRPr lang="en-US"/>
           </a:p>
         </p:txBody>
       </p:sp>
@@ -2666,38 +2662,37 @@
           <a:p>
             <a:pPr lvl="0"/>
             <a:r>
-              <a:rPr lang="en-US" smtClean="0"/>
+              <a:rPr lang="en-US"/>
               <a:t>Click to edit Master text styles</a:t>
             </a:r>
           </a:p>
           <a:p>
             <a:pPr lvl="1"/>
             <a:r>
-              <a:rPr lang="en-US" smtClean="0"/>
+              <a:rPr lang="en-US"/>
               <a:t>Second level</a:t>
             </a:r>
           </a:p>
           <a:p>
             <a:pPr lvl="2"/>
             <a:r>
-              <a:rPr lang="en-US" smtClean="0"/>
+              <a:rPr lang="en-US"/>
               <a:t>Third level</a:t>
             </a:r>
           </a:p>
           <a:p>
             <a:pPr lvl="3"/>
             <a:r>
-              <a:rPr lang="en-US" smtClean="0"/>
+              <a:rPr lang="en-US"/>
               <a:t>Fourth level</a:t>
             </a:r>
           </a:p>
           <a:p>
             <a:pPr lvl="4"/>
             <a:r>
-              <a:rPr lang="en-US" smtClean="0"/>
+              <a:rPr lang="en-US"/>
               <a:t>Fifth level</a:t>
             </a:r>
-            <a:endParaRPr lang="en-US"/>
           </a:p>
         </p:txBody>
       </p:sp>
@@ -2736,7 +2731,7 @@
           <a:p>
             <a:fld id="{5BCAD085-E8A6-8845-BD4E-CB4CCA059FC4}" type="datetimeFigureOut">
               <a:rPr lang="en-US" smtClean="0"/>
-              <a:t>1/27/13</a:t>
+              <a:t>6/25/2026</a:t>
             </a:fld>
             <a:endParaRPr lang="en-US"/>
           </a:p>
@@ -2814,7 +2809,7 @@
           <a:p>
             <a:fld id="{C1FF6DA9-008F-8B48-92A6-B652298478BF}" type="slidenum">
               <a:rPr lang="en-US" smtClean="0"/>
-              <a:t>‹#›</a:t>
+              <a:t>‹N°›</a:t>
             </a:fld>
             <a:endParaRPr lang="en-US"/>
           </a:p>
@@ -3095,7 +3090,7 @@
 </file>
 
 <file path=ppt/slides/slide1.xml><?xml version="1.0" encoding="utf-8"?>
-<p:sld xmlns:a="http://schemas.openxmlformats.org/drawingml/2006/main" xmlns:p="http://schemas.openxmlformats.org/presentationml/2006/main" xmlns:r="http://schemas.openxmlformats.org/officeDocument/2006/relationships">
+<p:sld xmlns:a="http://schemas.openxmlformats.org/drawingml/2006/main" xmlns:r="http://schemas.openxmlformats.org/officeDocument/2006/relationships" xmlns:p="http://schemas.openxmlformats.org/presentationml/2006/main">
   <p:cSld>
     <p:bg>
       <p:bgPr>
@@ -3111,7 +3106,14 @@
         <p:cNvGrpSpPr/>
         <p:nvPr/>
       </p:nvGrpSpPr>
-      <p:grpSpPr/>
+      <p:grpSpPr>
+        <a:xfrm>
+          <a:off x="0" y="0"/>
+          <a:ext cx="0" cy="0"/>
+          <a:chOff x="0" y="0"/>
+          <a:chExt cx="0" cy="0"/>
+        </a:xfrm>
+      </p:grpSpPr>
       <p:sp>
         <p:nvSpPr>
           <p:cNvPr id="2" name="TextBox 1"/>
@@ -3220,7 +3222,7 @@
         <p:spPr>
           <a:xfrm>
             <a:off x="731520" y="4754880"/>
-            <a:ext cx="2286000" cy="320040"/>
+            <a:ext cx="2011680" cy="320040"/>
           </a:xfrm>
           <a:prstGeom prst="roundRect">
             <a:avLst/>
@@ -3249,7 +3251,7 @@
           </a:fontRef>
         </p:style>
         <p:txBody>
-          <a:bodyPr rtlCol="0" anchor="ctr" wrap="square"/>
+          <a:bodyPr wrap="square" rtlCol="0" anchor="ctr"/>
           <a:lstStyle/>
           <a:p>
             <a:pPr algn="ctr">
@@ -3261,6 +3263,7 @@
               </a:defRPr>
             </a:pPr>
             <a:r>
+              <a:rPr dirty="0"/>
               <a:t>PROSPECTION TÉLÉPHONIQUE</a:t>
             </a:r>
           </a:p>
@@ -3274,8 +3277,8 @@
         </p:nvSpPr>
         <p:spPr>
           <a:xfrm>
-            <a:off x="3474720" y="4754880"/>
-            <a:ext cx="2286000" cy="320040"/>
+            <a:off x="2828239" y="4754880"/>
+            <a:ext cx="1643177" cy="320040"/>
           </a:xfrm>
           <a:prstGeom prst="roundRect">
             <a:avLst/>
@@ -3304,7 +3307,7 @@
           </a:fontRef>
         </p:style>
         <p:txBody>
-          <a:bodyPr rtlCol="0" anchor="ctr" wrap="square"/>
+          <a:bodyPr wrap="square" rtlCol="0" anchor="ctr"/>
           <a:lstStyle/>
           <a:p>
             <a:pPr algn="ctr">
@@ -3316,6 +3319,7 @@
               </a:defRPr>
             </a:pPr>
             <a:r>
+              <a:rPr dirty="0"/>
               <a:t>SOCIAL SELLING</a:t>
             </a:r>
           </a:p>
@@ -3329,8 +3333,8 @@
         </p:nvSpPr>
         <p:spPr>
           <a:xfrm>
-            <a:off x="5303520" y="4754880"/>
-            <a:ext cx="2286000" cy="320040"/>
+            <a:off x="4638903" y="4764024"/>
+            <a:ext cx="1457097" cy="320040"/>
           </a:xfrm>
           <a:prstGeom prst="roundRect">
             <a:avLst/>
@@ -3359,7 +3363,7 @@
           </a:fontRef>
         </p:style>
         <p:txBody>
-          <a:bodyPr rtlCol="0" anchor="ctr" wrap="square"/>
+          <a:bodyPr wrap="square" rtlCol="0" anchor="ctr"/>
           <a:lstStyle/>
           <a:p>
             <a:pPr algn="ctr">
@@ -3371,6 +3375,7 @@
               </a:defRPr>
             </a:pPr>
             <a:r>
+              <a:rPr dirty="0"/>
               <a:t>CLOSING STRIPE</a:t>
             </a:r>
           </a:p>
@@ -3392,8 +3397,8 @@
         </p:blipFill>
         <p:spPr>
           <a:xfrm>
-            <a:off x="6705295" y="0"/>
-            <a:ext cx="5486400" cy="6858000"/>
+            <a:off x="6583680" y="0"/>
+            <a:ext cx="5608015" cy="6858000"/>
           </a:xfrm>
           <a:prstGeom prst="rect">
             <a:avLst/>
@@ -3409,7 +3414,7 @@
 </file>
 
 <file path=ppt/slides/slide10.xml><?xml version="1.0" encoding="utf-8"?>
-<p:sld xmlns:a="http://schemas.openxmlformats.org/drawingml/2006/main" xmlns:p="http://schemas.openxmlformats.org/presentationml/2006/main" xmlns:r="http://schemas.openxmlformats.org/officeDocument/2006/relationships">
+<p:sld xmlns:a="http://schemas.openxmlformats.org/drawingml/2006/main" xmlns:r="http://schemas.openxmlformats.org/officeDocument/2006/relationships" xmlns:p="http://schemas.openxmlformats.org/presentationml/2006/main">
   <p:cSld>
     <p:bg>
       <p:bgPr>
@@ -3425,7 +3430,14 @@
         <p:cNvGrpSpPr/>
         <p:nvPr/>
       </p:nvGrpSpPr>
-      <p:grpSpPr/>
+      <p:grpSpPr>
+        <a:xfrm>
+          <a:off x="0" y="0"/>
+          <a:ext cx="0" cy="0"/>
+          <a:chOff x="0" y="0"/>
+          <a:chExt cx="0" cy="0"/>
+        </a:xfrm>
+      </p:grpSpPr>
       <p:sp>
         <p:nvSpPr>
           <p:cNvPr id="2" name="TextBox 1"/>
@@ -3540,6 +3552,7 @@
           <a:lstStyle/>
           <a:p>
             <a:pPr algn="ctr"/>
+            <a:endParaRPr/>
           </a:p>
         </p:txBody>
       </p:sp>
@@ -3585,6 +3598,7 @@
           <a:lstStyle/>
           <a:p>
             <a:pPr algn="ctr"/>
+            <a:endParaRPr/>
           </a:p>
         </p:txBody>
       </p:sp>
@@ -3666,6 +3680,7 @@
           <a:lstStyle/>
           <a:p>
             <a:pPr algn="ctr"/>
+            <a:endParaRPr/>
           </a:p>
         </p:txBody>
       </p:sp>
@@ -3747,6 +3762,7 @@
           <a:lstStyle/>
           <a:p>
             <a:pPr algn="ctr"/>
+            <a:endParaRPr/>
           </a:p>
         </p:txBody>
       </p:sp>
@@ -3828,6 +3844,7 @@
           <a:lstStyle/>
           <a:p>
             <a:pPr algn="ctr"/>
+            <a:endParaRPr/>
           </a:p>
         </p:txBody>
       </p:sp>
@@ -3909,6 +3926,7 @@
           <a:lstStyle/>
           <a:p>
             <a:pPr algn="ctr"/>
+            <a:endParaRPr/>
           </a:p>
         </p:txBody>
       </p:sp>
@@ -3990,6 +4008,7 @@
           <a:lstStyle/>
           <a:p>
             <a:pPr algn="ctr"/>
+            <a:endParaRPr/>
           </a:p>
         </p:txBody>
       </p:sp>
@@ -4071,6 +4090,7 @@
           <a:lstStyle/>
           <a:p>
             <a:pPr algn="ctr"/>
+            <a:endParaRPr/>
           </a:p>
         </p:txBody>
       </p:sp>
@@ -4152,6 +4172,7 @@
           <a:lstStyle/>
           <a:p>
             <a:pPr algn="ctr"/>
+            <a:endParaRPr/>
           </a:p>
         </p:txBody>
       </p:sp>
@@ -4233,6 +4254,7 @@
           <a:lstStyle/>
           <a:p>
             <a:pPr algn="ctr"/>
+            <a:endParaRPr/>
           </a:p>
         </p:txBody>
       </p:sp>
@@ -4314,6 +4336,7 @@
           <a:lstStyle/>
           <a:p>
             <a:pPr algn="ctr"/>
+            <a:endParaRPr/>
           </a:p>
         </p:txBody>
       </p:sp>
@@ -4395,6 +4418,7 @@
           <a:lstStyle/>
           <a:p>
             <a:pPr algn="ctr"/>
+            <a:endParaRPr/>
           </a:p>
         </p:txBody>
       </p:sp>
@@ -4476,6 +4500,7 @@
           <a:lstStyle/>
           <a:p>
             <a:pPr algn="ctr"/>
+            <a:endParaRPr/>
           </a:p>
         </p:txBody>
       </p:sp>
@@ -4557,6 +4582,7 @@
           <a:lstStyle/>
           <a:p>
             <a:pPr algn="ctr"/>
+            <a:endParaRPr/>
           </a:p>
         </p:txBody>
       </p:sp>
@@ -4638,6 +4664,7 @@
           <a:lstStyle/>
           <a:p>
             <a:pPr algn="ctr"/>
+            <a:endParaRPr/>
           </a:p>
         </p:txBody>
       </p:sp>
@@ -4719,6 +4746,7 @@
           <a:lstStyle/>
           <a:p>
             <a:pPr algn="ctr"/>
+            <a:endParaRPr/>
           </a:p>
         </p:txBody>
       </p:sp>
@@ -4731,7 +4759,7 @@
         <p:spPr>
           <a:xfrm>
             <a:off x="6327648" y="2761488"/>
-            <a:ext cx="2478024" cy="960120"/>
+            <a:ext cx="2478024" cy="823302"/>
           </a:xfrm>
           <a:prstGeom prst="rect">
             <a:avLst/>
@@ -4753,8 +4781,38 @@
               </a:defRPr>
             </a:pPr>
             <a:r>
-              <a:t>1. Tapez 'climatisation gainable [Ville cible]' sur Google.</a:t>
-            </a:r>
+              <a:rPr dirty="0"/>
+              <a:t>1. </a:t>
+            </a:r>
+            <a:r>
+              <a:rPr lang="fr-FR" dirty="0"/>
+              <a:t>Platform d’expert en climatisation </a:t>
+            </a:r>
+            <a:r>
+              <a:rPr dirty="0"/>
+              <a:t>[Ville </a:t>
+            </a:r>
+            <a:r>
+              <a:rPr dirty="0" err="1"/>
+              <a:t>cible</a:t>
+            </a:r>
+            <a:r>
+              <a:rPr dirty="0"/>
+              <a:t>]' sur Google.</a:t>
+            </a:r>
+            <a:r>
+              <a:rPr lang="fr-FR" dirty="0"/>
+              <a:t>  Ou Expert en climatisation gainable (ville)   ( </a:t>
+            </a:r>
+            <a:r>
+              <a:rPr lang="fr-FR" dirty="0" err="1"/>
+              <a:t>verification</a:t>
+            </a:r>
+            <a:r>
+              <a:rPr lang="fr-FR" dirty="0"/>
+              <a:t> d’indexation de son propre si il en as  site://domaine   pour voir le nombre </a:t>
+            </a:r>
+            <a:endParaRPr dirty="0"/>
           </a:p>
         </p:txBody>
       </p:sp>
@@ -4800,6 +4858,7 @@
           <a:lstStyle/>
           <a:p>
             <a:pPr algn="ctr"/>
+            <a:endParaRPr/>
           </a:p>
         </p:txBody>
       </p:sp>
@@ -4812,7 +4871,7 @@
         <p:spPr>
           <a:xfrm>
             <a:off x="6327648" y="3968496"/>
-            <a:ext cx="2478024" cy="960120"/>
+            <a:ext cx="2478024" cy="530915"/>
           </a:xfrm>
           <a:prstGeom prst="rect">
             <a:avLst/>
@@ -4834,8 +4893,49 @@
               </a:defRPr>
             </a:pPr>
             <a:r>
-              <a:t>2. Gainable.fr apparaît en haut. Montrez-le-lui.</a:t>
-            </a:r>
+              <a:rPr dirty="0"/>
+              <a:t>2. Gainable.fr </a:t>
+            </a:r>
+            <a:r>
+              <a:rPr dirty="0" err="1"/>
+              <a:t>apparaît</a:t>
+            </a:r>
+            <a:r>
+              <a:rPr dirty="0"/>
+              <a:t> </a:t>
+            </a:r>
+            <a:r>
+              <a:rPr dirty="0" err="1"/>
+              <a:t>en</a:t>
+            </a:r>
+            <a:r>
+              <a:rPr dirty="0"/>
+              <a:t> haut. Montrez-le-</a:t>
+            </a:r>
+            <a:r>
+              <a:rPr dirty="0" err="1"/>
+              <a:t>lui</a:t>
+            </a:r>
+            <a:r>
+              <a:rPr dirty="0"/>
+              <a:t>.</a:t>
+            </a:r>
+            <a:endParaRPr lang="fr-FR" dirty="0"/>
+          </a:p>
+          <a:p>
+            <a:pPr>
+              <a:defRPr sz="950">
+                <a:solidFill>
+                  <a:srgbClr val="64748B"/>
+                </a:solidFill>
+                <a:latin typeface="Arial"/>
+              </a:defRPr>
+            </a:pPr>
+            <a:r>
+              <a:rPr lang="fr-FR" dirty="0"/>
+              <a:t> nombre de page indexer </a:t>
+            </a:r>
+            <a:endParaRPr dirty="0"/>
           </a:p>
         </p:txBody>
       </p:sp>
@@ -4881,6 +4981,7 @@
           <a:lstStyle/>
           <a:p>
             <a:pPr algn="ctr"/>
+            <a:endParaRPr/>
           </a:p>
         </p:txBody>
       </p:sp>
@@ -4962,6 +5063,7 @@
           <a:lstStyle/>
           <a:p>
             <a:pPr algn="ctr"/>
+            <a:endParaRPr/>
           </a:p>
         </p:txBody>
       </p:sp>
@@ -5043,6 +5145,7 @@
           <a:lstStyle/>
           <a:p>
             <a:pPr algn="ctr"/>
+            <a:endParaRPr/>
           </a:p>
         </p:txBody>
       </p:sp>
@@ -5124,6 +5227,7 @@
           <a:lstStyle/>
           <a:p>
             <a:pPr algn="ctr"/>
+            <a:endParaRPr/>
           </a:p>
         </p:txBody>
       </p:sp>
@@ -5205,6 +5309,7 @@
           <a:lstStyle/>
           <a:p>
             <a:pPr algn="ctr"/>
+            <a:endParaRPr/>
           </a:p>
         </p:txBody>
       </p:sp>
@@ -5217,7 +5322,7 @@
         <p:spPr>
           <a:xfrm>
             <a:off x="9253728" y="2761488"/>
-            <a:ext cx="2478024" cy="960120"/>
+            <a:ext cx="2478024" cy="530915"/>
           </a:xfrm>
           <a:prstGeom prst="rect">
             <a:avLst/>
@@ -5239,8 +5344,38 @@
               </a:defRPr>
             </a:pPr>
             <a:r>
-              <a:t>1. Envoyez le lien de souscription Stripe EN DIRECT.</a:t>
-            </a:r>
+              <a:rPr dirty="0"/>
+              <a:t>1. </a:t>
+            </a:r>
+            <a:r>
+              <a:rPr dirty="0" err="1"/>
+              <a:t>Envoyez</a:t>
+            </a:r>
+            <a:r>
+              <a:rPr dirty="0"/>
+              <a:t> le lien de </a:t>
+            </a:r>
+            <a:r>
+              <a:rPr dirty="0" err="1"/>
+              <a:t>souscription</a:t>
+            </a:r>
+            <a:r>
+              <a:rPr dirty="0"/>
+              <a:t> Stripe EN DIRECT.</a:t>
+            </a:r>
+            <a:r>
+              <a:rPr lang="fr-FR" dirty="0"/>
+              <a:t> Ou plus orienter vert la page d’</a:t>
+            </a:r>
+            <a:r>
+              <a:rPr lang="fr-FR" dirty="0" err="1"/>
+              <a:t>adhesion</a:t>
+            </a:r>
+            <a:r>
+              <a:rPr lang="fr-FR" dirty="0"/>
+              <a:t> avec  code  promo</a:t>
+            </a:r>
+            <a:endParaRPr dirty="0"/>
           </a:p>
         </p:txBody>
       </p:sp>
@@ -5286,6 +5421,7 @@
           <a:lstStyle/>
           <a:p>
             <a:pPr algn="ctr"/>
+            <a:endParaRPr/>
           </a:p>
         </p:txBody>
       </p:sp>
@@ -5320,7 +5456,56 @@
               </a:defRPr>
             </a:pPr>
             <a:r>
-              <a:t>2. Restez en ligne avec lui pendant la saisie. Ne raccrochez pas.</a:t>
+              <a:rPr dirty="0"/>
+              <a:t>2. </a:t>
+            </a:r>
+            <a:r>
+              <a:rPr dirty="0" err="1"/>
+              <a:t>Restez</a:t>
+            </a:r>
+            <a:r>
+              <a:rPr dirty="0"/>
+              <a:t> </a:t>
+            </a:r>
+            <a:r>
+              <a:rPr dirty="0" err="1"/>
+              <a:t>en</a:t>
+            </a:r>
+            <a:r>
+              <a:rPr dirty="0"/>
+              <a:t> </a:t>
+            </a:r>
+            <a:r>
+              <a:rPr dirty="0" err="1"/>
+              <a:t>ligne</a:t>
+            </a:r>
+            <a:r>
+              <a:rPr dirty="0"/>
+              <a:t> avec </a:t>
+            </a:r>
+            <a:r>
+              <a:rPr dirty="0" err="1"/>
+              <a:t>lui</a:t>
+            </a:r>
+            <a:r>
+              <a:rPr dirty="0"/>
+              <a:t> pendant la </a:t>
+            </a:r>
+            <a:r>
+              <a:rPr dirty="0" err="1"/>
+              <a:t>saisie</a:t>
+            </a:r>
+            <a:r>
+              <a:rPr dirty="0"/>
+              <a:t>. Ne </a:t>
+            </a:r>
+            <a:r>
+              <a:rPr dirty="0" err="1"/>
+              <a:t>raccrochez</a:t>
+            </a:r>
+            <a:r>
+              <a:rPr dirty="0"/>
+              <a:t> pas.</a:t>
             </a:r>
           </a:p>
         </p:txBody>
@@ -5367,6 +5552,7 @@
           <a:lstStyle/>
           <a:p>
             <a:pPr algn="ctr"/>
+            <a:endParaRPr/>
           </a:p>
         </p:txBody>
       </p:sp>
@@ -5448,6 +5634,7 @@
           <a:lstStyle/>
           <a:p>
             <a:pPr algn="ctr"/>
+            <a:endParaRPr/>
           </a:p>
         </p:txBody>
       </p:sp>
@@ -5496,7 +5683,7 @@
 </file>
 
 <file path=ppt/slides/slide11.xml><?xml version="1.0" encoding="utf-8"?>
-<p:sld xmlns:a="http://schemas.openxmlformats.org/drawingml/2006/main" xmlns:p="http://schemas.openxmlformats.org/presentationml/2006/main" xmlns:r="http://schemas.openxmlformats.org/officeDocument/2006/relationships">
+<p:sld xmlns:a="http://schemas.openxmlformats.org/drawingml/2006/main" xmlns:r="http://schemas.openxmlformats.org/officeDocument/2006/relationships" xmlns:p="http://schemas.openxmlformats.org/presentationml/2006/main">
   <p:cSld>
     <p:bg>
       <p:bgPr>
@@ -5512,7 +5699,14 @@
         <p:cNvGrpSpPr/>
         <p:nvPr/>
       </p:nvGrpSpPr>
-      <p:grpSpPr/>
+      <p:grpSpPr>
+        <a:xfrm>
+          <a:off x="0" y="0"/>
+          <a:ext cx="0" cy="0"/>
+          <a:chOff x="0" y="0"/>
+          <a:chExt cx="0" cy="0"/>
+        </a:xfrm>
+      </p:grpSpPr>
       <p:sp>
         <p:nvSpPr>
           <p:cNvPr id="2" name="TextBox 1"/>
@@ -5627,6 +5821,7 @@
           <a:lstStyle/>
           <a:p>
             <a:pPr algn="ctr"/>
+            <a:endParaRPr/>
           </a:p>
         </p:txBody>
       </p:sp>
@@ -5672,6 +5867,7 @@
           <a:lstStyle/>
           <a:p>
             <a:pPr algn="ctr"/>
+            <a:endParaRPr/>
           </a:p>
         </p:txBody>
       </p:sp>
@@ -5717,6 +5913,7 @@
           <a:lstStyle/>
           <a:p>
             <a:pPr algn="ctr"/>
+            <a:endParaRPr/>
           </a:p>
         </p:txBody>
       </p:sp>
@@ -5814,6 +6011,7 @@
           <a:lstStyle/>
           <a:p>
             <a:pPr algn="ctr"/>
+            <a:endParaRPr/>
           </a:p>
         </p:txBody>
       </p:sp>
@@ -5859,6 +6057,7 @@
           <a:lstStyle/>
           <a:p>
             <a:pPr algn="ctr"/>
+            <a:endParaRPr/>
           </a:p>
         </p:txBody>
       </p:sp>
@@ -5956,6 +6155,7 @@
           <a:lstStyle/>
           <a:p>
             <a:pPr algn="ctr"/>
+            <a:endParaRPr/>
           </a:p>
         </p:txBody>
       </p:sp>
@@ -6001,6 +6201,7 @@
           <a:lstStyle/>
           <a:p>
             <a:pPr algn="ctr"/>
+            <a:endParaRPr/>
           </a:p>
         </p:txBody>
       </p:sp>
@@ -6098,6 +6299,7 @@
           <a:lstStyle/>
           <a:p>
             <a:pPr algn="ctr"/>
+            <a:endParaRPr/>
           </a:p>
         </p:txBody>
       </p:sp>
@@ -6143,6 +6345,7 @@
           <a:lstStyle/>
           <a:p>
             <a:pPr algn="ctr"/>
+            <a:endParaRPr/>
           </a:p>
         </p:txBody>
       </p:sp>
@@ -6240,6 +6443,7 @@
           <a:lstStyle/>
           <a:p>
             <a:pPr algn="ctr"/>
+            <a:endParaRPr/>
           </a:p>
         </p:txBody>
       </p:sp>
@@ -6285,6 +6489,7 @@
           <a:lstStyle/>
           <a:p>
             <a:pPr algn="ctr"/>
+            <a:endParaRPr/>
           </a:p>
         </p:txBody>
       </p:sp>
@@ -6382,6 +6587,7 @@
           <a:lstStyle/>
           <a:p>
             <a:pPr algn="ctr"/>
+            <a:endParaRPr/>
           </a:p>
         </p:txBody>
       </p:sp>
@@ -6427,6 +6633,7 @@
           <a:lstStyle/>
           <a:p>
             <a:pPr algn="ctr"/>
+            <a:endParaRPr/>
           </a:p>
         </p:txBody>
       </p:sp>
@@ -6524,6 +6731,7 @@
           <a:lstStyle/>
           <a:p>
             <a:pPr algn="ctr"/>
+            <a:endParaRPr/>
           </a:p>
         </p:txBody>
       </p:sp>
@@ -6569,6 +6777,7 @@
           <a:lstStyle/>
           <a:p>
             <a:pPr algn="ctr"/>
+            <a:endParaRPr/>
           </a:p>
         </p:txBody>
       </p:sp>
@@ -6666,6 +6875,7 @@
           <a:lstStyle/>
           <a:p>
             <a:pPr algn="ctr"/>
+            <a:endParaRPr/>
           </a:p>
         </p:txBody>
       </p:sp>
@@ -6711,6 +6921,7 @@
           <a:lstStyle/>
           <a:p>
             <a:pPr algn="ctr"/>
+            <a:endParaRPr/>
           </a:p>
         </p:txBody>
       </p:sp>
@@ -6775,7 +6986,7 @@
 </file>
 
 <file path=ppt/slides/slide12.xml><?xml version="1.0" encoding="utf-8"?>
-<p:sld xmlns:a="http://schemas.openxmlformats.org/drawingml/2006/main" xmlns:p="http://schemas.openxmlformats.org/presentationml/2006/main" xmlns:r="http://schemas.openxmlformats.org/officeDocument/2006/relationships">
+<p:sld xmlns:a="http://schemas.openxmlformats.org/drawingml/2006/main" xmlns:r="http://schemas.openxmlformats.org/officeDocument/2006/relationships" xmlns:p="http://schemas.openxmlformats.org/presentationml/2006/main">
   <p:cSld>
     <p:bg>
       <p:bgPr>
@@ -6791,7 +7002,14 @@
         <p:cNvGrpSpPr/>
         <p:nvPr/>
       </p:nvGrpSpPr>
-      <p:grpSpPr/>
+      <p:grpSpPr>
+        <a:xfrm>
+          <a:off x="0" y="0"/>
+          <a:ext cx="0" cy="0"/>
+          <a:chOff x="0" y="0"/>
+          <a:chExt cx="0" cy="0"/>
+        </a:xfrm>
+      </p:grpSpPr>
       <p:sp>
         <p:nvSpPr>
           <p:cNvPr id="2" name="TextBox 1"/>
@@ -6886,6 +7104,7 @@
           <a:lstStyle/>
           <a:p>
             <a:pPr algn="ctr"/>
+            <a:endParaRPr/>
           </a:p>
         </p:txBody>
       </p:sp>
@@ -6931,6 +7150,7 @@
           <a:lstStyle/>
           <a:p>
             <a:pPr algn="ctr"/>
+            <a:endParaRPr/>
           </a:p>
         </p:txBody>
       </p:sp>
@@ -7100,6 +7320,7 @@
           <a:lstStyle/>
           <a:p>
             <a:pPr algn="ctr"/>
+            <a:endParaRPr/>
           </a:p>
         </p:txBody>
       </p:sp>
@@ -7145,6 +7366,7 @@
           <a:lstStyle/>
           <a:p>
             <a:pPr algn="ctr"/>
+            <a:endParaRPr/>
           </a:p>
         </p:txBody>
       </p:sp>
@@ -7314,6 +7536,7 @@
           <a:lstStyle/>
           <a:p>
             <a:pPr algn="ctr"/>
+            <a:endParaRPr/>
           </a:p>
         </p:txBody>
       </p:sp>
@@ -7359,6 +7582,7 @@
           <a:lstStyle/>
           <a:p>
             <a:pPr algn="ctr"/>
+            <a:endParaRPr/>
           </a:p>
         </p:txBody>
       </p:sp>
@@ -7528,6 +7752,7 @@
           <a:lstStyle/>
           <a:p>
             <a:pPr algn="ctr"/>
+            <a:endParaRPr/>
           </a:p>
         </p:txBody>
       </p:sp>
@@ -7573,6 +7798,7 @@
           <a:lstStyle/>
           <a:p>
             <a:pPr algn="ctr"/>
+            <a:endParaRPr/>
           </a:p>
         </p:txBody>
       </p:sp>
@@ -7742,6 +7968,7 @@
           <a:lstStyle/>
           <a:p>
             <a:pPr algn="ctr"/>
+            <a:endParaRPr/>
           </a:p>
         </p:txBody>
       </p:sp>
@@ -7787,6 +8014,7 @@
           <a:lstStyle/>
           <a:p>
             <a:pPr algn="ctr"/>
+            <a:endParaRPr/>
           </a:p>
         </p:txBody>
       </p:sp>
@@ -7956,6 +8184,7 @@
           <a:lstStyle/>
           <a:p>
             <a:pPr algn="ctr"/>
+            <a:endParaRPr/>
           </a:p>
         </p:txBody>
       </p:sp>
@@ -8004,7 +8233,7 @@
 </file>
 
 <file path=ppt/slides/slide13.xml><?xml version="1.0" encoding="utf-8"?>
-<p:sld xmlns:a="http://schemas.openxmlformats.org/drawingml/2006/main" xmlns:p="http://schemas.openxmlformats.org/presentationml/2006/main" xmlns:r="http://schemas.openxmlformats.org/officeDocument/2006/relationships">
+<p:sld xmlns:a="http://schemas.openxmlformats.org/drawingml/2006/main" xmlns:r="http://schemas.openxmlformats.org/officeDocument/2006/relationships" xmlns:p="http://schemas.openxmlformats.org/presentationml/2006/main">
   <p:cSld>
     <p:bg>
       <p:bgPr>
@@ -8020,7 +8249,14 @@
         <p:cNvGrpSpPr/>
         <p:nvPr/>
       </p:nvGrpSpPr>
-      <p:grpSpPr/>
+      <p:grpSpPr>
+        <a:xfrm>
+          <a:off x="0" y="0"/>
+          <a:ext cx="0" cy="0"/>
+          <a:chOff x="0" y="0"/>
+          <a:chExt cx="0" cy="0"/>
+        </a:xfrm>
+      </p:grpSpPr>
       <p:sp>
         <p:nvSpPr>
           <p:cNvPr id="2" name="TextBox 1"/>
@@ -8135,6 +8371,7 @@
           <a:lstStyle/>
           <a:p>
             <a:pPr algn="ctr"/>
+            <a:endParaRPr/>
           </a:p>
         </p:txBody>
       </p:sp>
@@ -8176,7 +8413,7 @@
           </a:fontRef>
         </p:style>
         <p:txBody>
-          <a:bodyPr rtlCol="0" anchor="ctr" wrap="square"/>
+          <a:bodyPr wrap="square" rtlCol="0" anchor="ctr"/>
           <a:lstStyle/>
           <a:p>
             <a:pPr algn="ctr">
@@ -8235,6 +8472,7 @@
           <a:lstStyle/>
           <a:p>
             <a:pPr algn="ctr"/>
+            <a:endParaRPr/>
           </a:p>
         </p:txBody>
       </p:sp>
@@ -8532,6 +8770,7 @@
           <a:lstStyle/>
           <a:p>
             <a:pPr algn="ctr"/>
+            <a:endParaRPr/>
           </a:p>
         </p:txBody>
       </p:sp>
@@ -8829,6 +9068,7 @@
           <a:lstStyle/>
           <a:p>
             <a:pPr algn="ctr"/>
+            <a:endParaRPr/>
           </a:p>
         </p:txBody>
       </p:sp>
@@ -9126,6 +9366,7 @@
           <a:lstStyle/>
           <a:p>
             <a:pPr algn="ctr"/>
+            <a:endParaRPr/>
           </a:p>
         </p:txBody>
       </p:sp>
@@ -9423,6 +9664,7 @@
           <a:lstStyle/>
           <a:p>
             <a:pPr algn="ctr"/>
+            <a:endParaRPr/>
           </a:p>
         </p:txBody>
       </p:sp>
@@ -9720,6 +9962,7 @@
           <a:lstStyle/>
           <a:p>
             <a:pPr algn="ctr"/>
+            <a:endParaRPr/>
           </a:p>
         </p:txBody>
       </p:sp>
@@ -10017,6 +10260,7 @@
           <a:lstStyle/>
           <a:p>
             <a:pPr algn="ctr"/>
+            <a:endParaRPr/>
           </a:p>
         </p:txBody>
       </p:sp>
@@ -10314,6 +10558,7 @@
           <a:lstStyle/>
           <a:p>
             <a:pPr algn="ctr"/>
+            <a:endParaRPr/>
           </a:p>
         </p:txBody>
       </p:sp>
@@ -10611,6 +10856,7 @@
           <a:lstStyle/>
           <a:p>
             <a:pPr algn="ctr"/>
+            <a:endParaRPr/>
           </a:p>
         </p:txBody>
       </p:sp>
@@ -10908,6 +11154,7 @@
           <a:lstStyle/>
           <a:p>
             <a:pPr algn="ctr"/>
+            <a:endParaRPr/>
           </a:p>
         </p:txBody>
       </p:sp>
@@ -10956,7 +11203,7 @@
 </file>
 
 <file path=ppt/slides/slide14.xml><?xml version="1.0" encoding="utf-8"?>
-<p:sld xmlns:a="http://schemas.openxmlformats.org/drawingml/2006/main" xmlns:p="http://schemas.openxmlformats.org/presentationml/2006/main" xmlns:r="http://schemas.openxmlformats.org/officeDocument/2006/relationships">
+<p:sld xmlns:a="http://schemas.openxmlformats.org/drawingml/2006/main" xmlns:r="http://schemas.openxmlformats.org/officeDocument/2006/relationships" xmlns:p="http://schemas.openxmlformats.org/presentationml/2006/main">
   <p:cSld>
     <p:bg>
       <p:bgPr>
@@ -10972,7 +11219,14 @@
         <p:cNvGrpSpPr/>
         <p:nvPr/>
       </p:nvGrpSpPr>
-      <p:grpSpPr/>
+      <p:grpSpPr>
+        <a:xfrm>
+          <a:off x="0" y="0"/>
+          <a:ext cx="0" cy="0"/>
+          <a:chOff x="0" y="0"/>
+          <a:chExt cx="0" cy="0"/>
+        </a:xfrm>
+      </p:grpSpPr>
       <p:sp>
         <p:nvSpPr>
           <p:cNvPr id="2" name="TextBox 1"/>
@@ -11087,6 +11341,7 @@
           <a:lstStyle/>
           <a:p>
             <a:pPr algn="ctr"/>
+            <a:endParaRPr/>
           </a:p>
         </p:txBody>
       </p:sp>
@@ -11132,6 +11387,7 @@
           <a:lstStyle/>
           <a:p>
             <a:pPr algn="ctr"/>
+            <a:endParaRPr/>
           </a:p>
         </p:txBody>
       </p:sp>
@@ -11226,6 +11482,7 @@
           <a:lstStyle/>
           <a:p>
             <a:pPr algn="ctr"/>
+            <a:endParaRPr/>
           </a:p>
         </p:txBody>
       </p:sp>
@@ -11271,6 +11528,7 @@
           <a:lstStyle/>
           <a:p>
             <a:pPr algn="ctr"/>
+            <a:endParaRPr/>
           </a:p>
         </p:txBody>
       </p:sp>
@@ -11419,6 +11677,7 @@
           <a:lstStyle/>
           <a:p>
             <a:pPr algn="ctr"/>
+            <a:endParaRPr/>
           </a:p>
         </p:txBody>
       </p:sp>
@@ -11464,6 +11723,7 @@
           <a:lstStyle/>
           <a:p>
             <a:pPr algn="ctr"/>
+            <a:endParaRPr/>
           </a:p>
         </p:txBody>
       </p:sp>
@@ -11612,6 +11872,7 @@
           <a:lstStyle/>
           <a:p>
             <a:pPr algn="ctr"/>
+            <a:endParaRPr/>
           </a:p>
         </p:txBody>
       </p:sp>
@@ -11657,6 +11918,7 @@
           <a:lstStyle/>
           <a:p>
             <a:pPr algn="ctr"/>
+            <a:endParaRPr/>
           </a:p>
         </p:txBody>
       </p:sp>
@@ -11805,6 +12067,7 @@
           <a:lstStyle/>
           <a:p>
             <a:pPr algn="ctr"/>
+            <a:endParaRPr/>
           </a:p>
         </p:txBody>
       </p:sp>
@@ -11850,6 +12113,7 @@
           <a:lstStyle/>
           <a:p>
             <a:pPr algn="ctr"/>
+            <a:endParaRPr/>
           </a:p>
         </p:txBody>
       </p:sp>
@@ -11998,6 +12262,7 @@
           <a:lstStyle/>
           <a:p>
             <a:pPr algn="ctr"/>
+            <a:endParaRPr/>
           </a:p>
         </p:txBody>
       </p:sp>
@@ -12043,6 +12308,7 @@
           <a:lstStyle/>
           <a:p>
             <a:pPr algn="ctr"/>
+            <a:endParaRPr/>
           </a:p>
         </p:txBody>
       </p:sp>
@@ -12191,6 +12457,7 @@
           <a:lstStyle/>
           <a:p>
             <a:pPr algn="ctr"/>
+            <a:endParaRPr/>
           </a:p>
         </p:txBody>
       </p:sp>
@@ -12236,6 +12503,7 @@
           <a:lstStyle/>
           <a:p>
             <a:pPr algn="ctr"/>
+            <a:endParaRPr/>
           </a:p>
         </p:txBody>
       </p:sp>
@@ -12384,6 +12652,7 @@
           <a:lstStyle/>
           <a:p>
             <a:pPr algn="ctr"/>
+            <a:endParaRPr/>
           </a:p>
         </p:txBody>
       </p:sp>
@@ -12432,7 +12701,7 @@
 </file>
 
 <file path=ppt/slides/slide15.xml><?xml version="1.0" encoding="utf-8"?>
-<p:sld xmlns:a="http://schemas.openxmlformats.org/drawingml/2006/main" xmlns:p="http://schemas.openxmlformats.org/presentationml/2006/main" xmlns:r="http://schemas.openxmlformats.org/officeDocument/2006/relationships">
+<p:sld xmlns:a="http://schemas.openxmlformats.org/drawingml/2006/main" xmlns:r="http://schemas.openxmlformats.org/officeDocument/2006/relationships" xmlns:p="http://schemas.openxmlformats.org/presentationml/2006/main">
   <p:cSld>
     <p:bg>
       <p:bgPr>
@@ -12448,7 +12717,14 @@
         <p:cNvGrpSpPr/>
         <p:nvPr/>
       </p:nvGrpSpPr>
-      <p:grpSpPr/>
+      <p:grpSpPr>
+        <a:xfrm>
+          <a:off x="0" y="0"/>
+          <a:ext cx="0" cy="0"/>
+          <a:chOff x="0" y="0"/>
+          <a:chExt cx="0" cy="0"/>
+        </a:xfrm>
+      </p:grpSpPr>
       <p:sp>
         <p:nvSpPr>
           <p:cNvPr id="2" name="TextBox 1"/>
@@ -12563,6 +12839,7 @@
           <a:lstStyle/>
           <a:p>
             <a:pPr algn="ctr"/>
+            <a:endParaRPr/>
           </a:p>
         </p:txBody>
       </p:sp>
@@ -12608,6 +12885,7 @@
           <a:lstStyle/>
           <a:p>
             <a:pPr algn="ctr"/>
+            <a:endParaRPr/>
           </a:p>
         </p:txBody>
       </p:sp>
@@ -12653,6 +12931,7 @@
           <a:lstStyle/>
           <a:p>
             <a:pPr algn="ctr"/>
+            <a:endParaRPr/>
           </a:p>
         </p:txBody>
       </p:sp>
@@ -12869,6 +13148,7 @@
           <a:lstStyle/>
           <a:p>
             <a:pPr algn="ctr"/>
+            <a:endParaRPr/>
           </a:p>
         </p:txBody>
       </p:sp>
@@ -12950,6 +13230,7 @@
           <a:lstStyle/>
           <a:p>
             <a:pPr algn="ctr"/>
+            <a:endParaRPr/>
           </a:p>
         </p:txBody>
       </p:sp>
@@ -12995,6 +13276,7 @@
           <a:lstStyle/>
           <a:p>
             <a:pPr algn="ctr"/>
+            <a:endParaRPr/>
           </a:p>
         </p:txBody>
       </p:sp>
@@ -13211,6 +13493,7 @@
           <a:lstStyle/>
           <a:p>
             <a:pPr algn="ctr"/>
+            <a:endParaRPr/>
           </a:p>
         </p:txBody>
       </p:sp>
@@ -13292,6 +13575,7 @@
           <a:lstStyle/>
           <a:p>
             <a:pPr algn="ctr"/>
+            <a:endParaRPr/>
           </a:p>
         </p:txBody>
       </p:sp>
@@ -13337,6 +13621,7 @@
           <a:lstStyle/>
           <a:p>
             <a:pPr algn="ctr"/>
+            <a:endParaRPr/>
           </a:p>
         </p:txBody>
       </p:sp>
@@ -13553,6 +13838,7 @@
           <a:lstStyle/>
           <a:p>
             <a:pPr algn="ctr"/>
+            <a:endParaRPr/>
           </a:p>
         </p:txBody>
       </p:sp>
@@ -13601,7 +13887,7 @@
 </file>
 
 <file path=ppt/slides/slide16.xml><?xml version="1.0" encoding="utf-8"?>
-<p:sld xmlns:a="http://schemas.openxmlformats.org/drawingml/2006/main" xmlns:p="http://schemas.openxmlformats.org/presentationml/2006/main" xmlns:r="http://schemas.openxmlformats.org/officeDocument/2006/relationships">
+<p:sld xmlns:a="http://schemas.openxmlformats.org/drawingml/2006/main" xmlns:r="http://schemas.openxmlformats.org/officeDocument/2006/relationships" xmlns:p="http://schemas.openxmlformats.org/presentationml/2006/main">
   <p:cSld>
     <p:bg>
       <p:bgPr>
@@ -13617,7 +13903,14 @@
         <p:cNvGrpSpPr/>
         <p:nvPr/>
       </p:nvGrpSpPr>
-      <p:grpSpPr/>
+      <p:grpSpPr>
+        <a:xfrm>
+          <a:off x="0" y="0"/>
+          <a:ext cx="0" cy="0"/>
+          <a:chOff x="0" y="0"/>
+          <a:chExt cx="0" cy="0"/>
+        </a:xfrm>
+      </p:grpSpPr>
       <p:sp>
         <p:nvSpPr>
           <p:cNvPr id="2" name="TextBox 1"/>
@@ -13712,6 +14005,7 @@
           <a:lstStyle/>
           <a:p>
             <a:pPr algn="ctr"/>
+            <a:endParaRPr/>
           </a:p>
         </p:txBody>
       </p:sp>
@@ -13757,6 +14051,7 @@
           <a:lstStyle/>
           <a:p>
             <a:pPr algn="ctr"/>
+            <a:endParaRPr/>
           </a:p>
         </p:txBody>
       </p:sp>
@@ -13870,6 +14165,7 @@
           <a:lstStyle/>
           <a:p>
             <a:pPr algn="ctr"/>
+            <a:endParaRPr/>
           </a:p>
         </p:txBody>
       </p:sp>
@@ -13915,6 +14211,7 @@
           <a:lstStyle/>
           <a:p>
             <a:pPr algn="ctr"/>
+            <a:endParaRPr/>
           </a:p>
         </p:txBody>
       </p:sp>
@@ -14028,6 +14325,7 @@
           <a:lstStyle/>
           <a:p>
             <a:pPr algn="ctr"/>
+            <a:endParaRPr/>
           </a:p>
         </p:txBody>
       </p:sp>
@@ -14073,6 +14371,7 @@
           <a:lstStyle/>
           <a:p>
             <a:pPr algn="ctr"/>
+            <a:endParaRPr/>
           </a:p>
         </p:txBody>
       </p:sp>
@@ -14186,6 +14485,7 @@
           <a:lstStyle/>
           <a:p>
             <a:pPr algn="ctr"/>
+            <a:endParaRPr/>
           </a:p>
         </p:txBody>
       </p:sp>
@@ -14231,6 +14531,7 @@
           <a:lstStyle/>
           <a:p>
             <a:pPr algn="ctr"/>
+            <a:endParaRPr/>
           </a:p>
         </p:txBody>
       </p:sp>
@@ -14344,6 +14645,7 @@
           <a:lstStyle/>
           <a:p>
             <a:pPr algn="ctr"/>
+            <a:endParaRPr/>
           </a:p>
         </p:txBody>
       </p:sp>
@@ -14389,6 +14691,7 @@
           <a:lstStyle/>
           <a:p>
             <a:pPr algn="ctr"/>
+            <a:endParaRPr/>
           </a:p>
         </p:txBody>
       </p:sp>
@@ -14502,6 +14805,7 @@
           <a:lstStyle/>
           <a:p>
             <a:pPr algn="ctr"/>
+            <a:endParaRPr/>
           </a:p>
         </p:txBody>
       </p:sp>
@@ -14547,6 +14851,7 @@
           <a:lstStyle/>
           <a:p>
             <a:pPr algn="ctr"/>
+            <a:endParaRPr/>
           </a:p>
         </p:txBody>
       </p:sp>
@@ -14627,7 +14932,7 @@
 </file>
 
 <file path=ppt/slides/slide17.xml><?xml version="1.0" encoding="utf-8"?>
-<p:sld xmlns:a="http://schemas.openxmlformats.org/drawingml/2006/main" xmlns:p="http://schemas.openxmlformats.org/presentationml/2006/main" xmlns:r="http://schemas.openxmlformats.org/officeDocument/2006/relationships">
+<p:sld xmlns:a="http://schemas.openxmlformats.org/drawingml/2006/main" xmlns:r="http://schemas.openxmlformats.org/officeDocument/2006/relationships" xmlns:p="http://schemas.openxmlformats.org/presentationml/2006/main">
   <p:cSld>
     <p:bg>
       <p:bgPr>
@@ -14643,7 +14948,14 @@
         <p:cNvGrpSpPr/>
         <p:nvPr/>
       </p:nvGrpSpPr>
-      <p:grpSpPr/>
+      <p:grpSpPr>
+        <a:xfrm>
+          <a:off x="0" y="0"/>
+          <a:ext cx="0" cy="0"/>
+          <a:chOff x="0" y="0"/>
+          <a:chExt cx="0" cy="0"/>
+        </a:xfrm>
+      </p:grpSpPr>
       <p:sp>
         <p:nvSpPr>
           <p:cNvPr id="2" name="TextBox 1"/>
@@ -14774,6 +15086,7 @@
           <a:lstStyle/>
           <a:p>
             <a:pPr algn="ctr"/>
+            <a:endParaRPr/>
           </a:p>
         </p:txBody>
       </p:sp>
@@ -14819,6 +15132,7 @@
           <a:lstStyle/>
           <a:p>
             <a:pPr algn="ctr"/>
+            <a:endParaRPr/>
           </a:p>
         </p:txBody>
       </p:sp>
@@ -14864,6 +15178,7 @@
           <a:lstStyle/>
           <a:p>
             <a:pPr algn="ctr"/>
+            <a:endParaRPr/>
           </a:p>
         </p:txBody>
       </p:sp>
@@ -14909,6 +15224,7 @@
           <a:lstStyle/>
           <a:p>
             <a:pPr algn="ctr"/>
+            <a:endParaRPr/>
           </a:p>
         </p:txBody>
       </p:sp>
@@ -14954,6 +15270,7 @@
           <a:lstStyle/>
           <a:p>
             <a:pPr algn="ctr"/>
+            <a:endParaRPr/>
           </a:p>
         </p:txBody>
       </p:sp>
@@ -15102,6 +15419,7 @@
           <a:lstStyle/>
           <a:p>
             <a:pPr algn="ctr"/>
+            <a:endParaRPr/>
           </a:p>
         </p:txBody>
       </p:sp>
@@ -15147,6 +15465,7 @@
           <a:lstStyle/>
           <a:p>
             <a:pPr algn="ctr"/>
+            <a:endParaRPr/>
           </a:p>
         </p:txBody>
       </p:sp>
@@ -15192,6 +15511,7 @@
           <a:lstStyle/>
           <a:p>
             <a:pPr algn="ctr"/>
+            <a:endParaRPr/>
           </a:p>
         </p:txBody>
       </p:sp>
@@ -15340,6 +15660,7 @@
           <a:lstStyle/>
           <a:p>
             <a:pPr algn="ctr"/>
+            <a:endParaRPr/>
           </a:p>
         </p:txBody>
       </p:sp>
@@ -15385,6 +15706,7 @@
           <a:lstStyle/>
           <a:p>
             <a:pPr algn="ctr"/>
+            <a:endParaRPr/>
           </a:p>
         </p:txBody>
       </p:sp>
@@ -15430,6 +15752,7 @@
           <a:lstStyle/>
           <a:p>
             <a:pPr algn="ctr"/>
+            <a:endParaRPr/>
           </a:p>
         </p:txBody>
       </p:sp>
@@ -15578,6 +15901,7 @@
           <a:lstStyle/>
           <a:p>
             <a:pPr algn="ctr"/>
+            <a:endParaRPr/>
           </a:p>
         </p:txBody>
       </p:sp>
@@ -15623,6 +15947,7 @@
           <a:lstStyle/>
           <a:p>
             <a:pPr algn="ctr"/>
+            <a:endParaRPr/>
           </a:p>
         </p:txBody>
       </p:sp>
@@ -15668,6 +15993,7 @@
           <a:lstStyle/>
           <a:p>
             <a:pPr algn="ctr"/>
+            <a:endParaRPr/>
           </a:p>
         </p:txBody>
       </p:sp>
@@ -15816,6 +16142,7 @@
           <a:lstStyle/>
           <a:p>
             <a:pPr algn="ctr"/>
+            <a:endParaRPr/>
           </a:p>
         </p:txBody>
       </p:sp>
@@ -15864,7 +16191,7 @@
 </file>
 
 <file path=ppt/slides/slide2.xml><?xml version="1.0" encoding="utf-8"?>
-<p:sld xmlns:a="http://schemas.openxmlformats.org/drawingml/2006/main" xmlns:p="http://schemas.openxmlformats.org/presentationml/2006/main" xmlns:r="http://schemas.openxmlformats.org/officeDocument/2006/relationships">
+<p:sld xmlns:a="http://schemas.openxmlformats.org/drawingml/2006/main" xmlns:r="http://schemas.openxmlformats.org/officeDocument/2006/relationships" xmlns:p="http://schemas.openxmlformats.org/presentationml/2006/main">
   <p:cSld>
     <p:bg>
       <p:bgPr>
@@ -15880,7 +16207,14 @@
         <p:cNvGrpSpPr/>
         <p:nvPr/>
       </p:nvGrpSpPr>
-      <p:grpSpPr/>
+      <p:grpSpPr>
+        <a:xfrm>
+          <a:off x="0" y="0"/>
+          <a:ext cx="0" cy="0"/>
+          <a:chOff x="0" y="0"/>
+          <a:chExt cx="0" cy="0"/>
+        </a:xfrm>
+      </p:grpSpPr>
       <p:sp>
         <p:nvSpPr>
           <p:cNvPr id="2" name="TextBox 1"/>
@@ -15995,6 +16329,7 @@
           <a:lstStyle/>
           <a:p>
             <a:pPr algn="ctr"/>
+            <a:endParaRPr/>
           </a:p>
         </p:txBody>
       </p:sp>
@@ -17567,7 +17902,7 @@
 </file>
 
 <file path=ppt/slides/slide3.xml><?xml version="1.0" encoding="utf-8"?>
-<p:sld xmlns:a="http://schemas.openxmlformats.org/drawingml/2006/main" xmlns:p="http://schemas.openxmlformats.org/presentationml/2006/main" xmlns:r="http://schemas.openxmlformats.org/officeDocument/2006/relationships">
+<p:sld xmlns:a="http://schemas.openxmlformats.org/drawingml/2006/main" xmlns:r="http://schemas.openxmlformats.org/officeDocument/2006/relationships" xmlns:p="http://schemas.openxmlformats.org/presentationml/2006/main">
   <p:cSld>
     <p:bg>
       <p:bgPr>
@@ -17583,7 +17918,14 @@
         <p:cNvGrpSpPr/>
         <p:nvPr/>
       </p:nvGrpSpPr>
-      <p:grpSpPr/>
+      <p:grpSpPr>
+        <a:xfrm>
+          <a:off x="0" y="0"/>
+          <a:ext cx="0" cy="0"/>
+          <a:chOff x="0" y="0"/>
+          <a:chExt cx="0" cy="0"/>
+        </a:xfrm>
+      </p:grpSpPr>
       <p:sp>
         <p:nvSpPr>
           <p:cNvPr id="2" name="TextBox 1"/>
@@ -17698,6 +18040,7 @@
           <a:lstStyle/>
           <a:p>
             <a:pPr algn="ctr"/>
+            <a:endParaRPr/>
           </a:p>
         </p:txBody>
       </p:sp>
@@ -17743,6 +18086,7 @@
           <a:lstStyle/>
           <a:p>
             <a:pPr algn="ctr"/>
+            <a:endParaRPr/>
           </a:p>
         </p:txBody>
       </p:sp>
@@ -17788,6 +18132,7 @@
           <a:lstStyle/>
           <a:p>
             <a:pPr algn="ctr"/>
+            <a:endParaRPr/>
           </a:p>
         </p:txBody>
       </p:sp>
@@ -17901,6 +18246,7 @@
           <a:lstStyle/>
           <a:p>
             <a:pPr algn="ctr"/>
+            <a:endParaRPr/>
           </a:p>
         </p:txBody>
       </p:sp>
@@ -17946,6 +18292,7 @@
           <a:lstStyle/>
           <a:p>
             <a:pPr algn="ctr"/>
+            <a:endParaRPr/>
           </a:p>
         </p:txBody>
       </p:sp>
@@ -18059,6 +18406,7 @@
           <a:lstStyle/>
           <a:p>
             <a:pPr algn="ctr"/>
+            <a:endParaRPr/>
           </a:p>
         </p:txBody>
       </p:sp>
@@ -18104,6 +18452,7 @@
           <a:lstStyle/>
           <a:p>
             <a:pPr algn="ctr"/>
+            <a:endParaRPr/>
           </a:p>
         </p:txBody>
       </p:sp>
@@ -18217,6 +18566,7 @@
           <a:lstStyle/>
           <a:p>
             <a:pPr algn="ctr"/>
+            <a:endParaRPr/>
           </a:p>
         </p:txBody>
       </p:sp>
@@ -18262,6 +18612,7 @@
           <a:lstStyle/>
           <a:p>
             <a:pPr algn="ctr"/>
+            <a:endParaRPr/>
           </a:p>
         </p:txBody>
       </p:sp>
@@ -18342,7 +18693,7 @@
 </file>
 
 <file path=ppt/slides/slide4.xml><?xml version="1.0" encoding="utf-8"?>
-<p:sld xmlns:a="http://schemas.openxmlformats.org/drawingml/2006/main" xmlns:p="http://schemas.openxmlformats.org/presentationml/2006/main" xmlns:r="http://schemas.openxmlformats.org/officeDocument/2006/relationships">
+<p:sld xmlns:a="http://schemas.openxmlformats.org/drawingml/2006/main" xmlns:r="http://schemas.openxmlformats.org/officeDocument/2006/relationships" xmlns:p="http://schemas.openxmlformats.org/presentationml/2006/main">
   <p:cSld>
     <p:bg>
       <p:bgPr>
@@ -18358,7 +18709,14 @@
         <p:cNvGrpSpPr/>
         <p:nvPr/>
       </p:nvGrpSpPr>
-      <p:grpSpPr/>
+      <p:grpSpPr>
+        <a:xfrm>
+          <a:off x="0" y="0"/>
+          <a:ext cx="0" cy="0"/>
+          <a:chOff x="0" y="0"/>
+          <a:chExt cx="0" cy="0"/>
+        </a:xfrm>
+      </p:grpSpPr>
       <p:sp>
         <p:nvSpPr>
           <p:cNvPr id="2" name="TextBox 1"/>
@@ -18473,6 +18831,7 @@
           <a:lstStyle/>
           <a:p>
             <a:pPr algn="ctr"/>
+            <a:endParaRPr/>
           </a:p>
         </p:txBody>
       </p:sp>
@@ -18514,7 +18873,7 @@
           </a:fontRef>
         </p:style>
         <p:txBody>
-          <a:bodyPr rtlCol="0" anchor="ctr" wrap="square"/>
+          <a:bodyPr wrap="square" rtlCol="0" anchor="ctr"/>
           <a:lstStyle/>
           <a:p>
             <a:pPr algn="ctr">
@@ -18641,6 +19000,7 @@
           <a:lstStyle/>
           <a:p>
             <a:pPr algn="ctr"/>
+            <a:endParaRPr/>
           </a:p>
         </p:txBody>
       </p:sp>
@@ -18754,6 +19114,7 @@
           <a:lstStyle/>
           <a:p>
             <a:pPr algn="ctr"/>
+            <a:endParaRPr/>
           </a:p>
         </p:txBody>
       </p:sp>
@@ -18935,6 +19296,7 @@
           <a:lstStyle/>
           <a:p>
             <a:pPr algn="ctr"/>
+            <a:endParaRPr/>
           </a:p>
         </p:txBody>
       </p:sp>
@@ -19048,6 +19410,7 @@
           <a:lstStyle/>
           <a:p>
             <a:pPr algn="ctr"/>
+            <a:endParaRPr/>
           </a:p>
         </p:txBody>
       </p:sp>
@@ -19128,7 +19491,7 @@
 </file>
 
 <file path=ppt/slides/slide5.xml><?xml version="1.0" encoding="utf-8"?>
-<p:sld xmlns:a="http://schemas.openxmlformats.org/drawingml/2006/main" xmlns:p="http://schemas.openxmlformats.org/presentationml/2006/main" xmlns:r="http://schemas.openxmlformats.org/officeDocument/2006/relationships">
+<p:sld xmlns:a="http://schemas.openxmlformats.org/drawingml/2006/main" xmlns:r="http://schemas.openxmlformats.org/officeDocument/2006/relationships" xmlns:p="http://schemas.openxmlformats.org/presentationml/2006/main">
   <p:cSld>
     <p:bg>
       <p:bgPr>
@@ -19144,7 +19507,14 @@
         <p:cNvGrpSpPr/>
         <p:nvPr/>
       </p:nvGrpSpPr>
-      <p:grpSpPr/>
+      <p:grpSpPr>
+        <a:xfrm>
+          <a:off x="0" y="0"/>
+          <a:ext cx="0" cy="0"/>
+          <a:chOff x="0" y="0"/>
+          <a:chExt cx="0" cy="0"/>
+        </a:xfrm>
+      </p:grpSpPr>
       <p:sp>
         <p:nvSpPr>
           <p:cNvPr id="2" name="TextBox 1"/>
@@ -19259,6 +19629,7 @@
           <a:lstStyle/>
           <a:p>
             <a:pPr algn="ctr"/>
+            <a:endParaRPr/>
           </a:p>
         </p:txBody>
       </p:sp>
@@ -19304,6 +19675,7 @@
           <a:lstStyle/>
           <a:p>
             <a:pPr algn="ctr"/>
+            <a:endParaRPr/>
           </a:p>
         </p:txBody>
       </p:sp>
@@ -19349,6 +19721,7 @@
           <a:lstStyle/>
           <a:p>
             <a:pPr algn="ctr"/>
+            <a:endParaRPr/>
           </a:p>
         </p:txBody>
       </p:sp>
@@ -19491,17 +19864,6 @@
           </a:p>
           <a:p>
             <a:br/>
-            <a:pPr>
-              <a:spcAft>
-                <a:spcPts val="400"/>
-              </a:spcAft>
-              <a:defRPr sz="950" b="1">
-                <a:solidFill>
-                  <a:srgbClr val="F97316"/>
-                </a:solidFill>
-                <a:latin typeface="Arial"/>
-              </a:defRPr>
-            </a:pPr>
             <a:r>
               <a:t>Posture : Ultra-direct + jargon technique</a:t>
             </a:r>
@@ -19614,6 +19976,7 @@
           <a:lstStyle/>
           <a:p>
             <a:pPr algn="ctr"/>
+            <a:endParaRPr/>
           </a:p>
         </p:txBody>
       </p:sp>
@@ -19659,6 +20022,7 @@
           <a:lstStyle/>
           <a:p>
             <a:pPr algn="ctr"/>
+            <a:endParaRPr/>
           </a:p>
         </p:txBody>
       </p:sp>
@@ -19801,17 +20165,6 @@
           </a:p>
           <a:p>
             <a:br/>
-            <a:pPr>
-              <a:spcAft>
-                <a:spcPts val="400"/>
-              </a:spcAft>
-              <a:defRPr sz="950" b="1">
-                <a:solidFill>
-                  <a:srgbClr val="EF4444"/>
-                </a:solidFill>
-                <a:latin typeface="Arial"/>
-              </a:defRPr>
-            </a:pPr>
             <a:r>
               <a:t>Posture : Empathie radicale + transparence totale</a:t>
             </a:r>
@@ -19924,6 +20277,7 @@
           <a:lstStyle/>
           <a:p>
             <a:pPr algn="ctr"/>
+            <a:endParaRPr/>
           </a:p>
         </p:txBody>
       </p:sp>
@@ -19969,6 +20323,7 @@
           <a:lstStyle/>
           <a:p>
             <a:pPr algn="ctr"/>
+            <a:endParaRPr/>
           </a:p>
         </p:txBody>
       </p:sp>
@@ -20111,17 +20466,6 @@
           </a:p>
           <a:p>
             <a:br/>
-            <a:pPr>
-              <a:spcAft>
-                <a:spcPts val="400"/>
-              </a:spcAft>
-              <a:defRPr sz="950" b="1">
-                <a:solidFill>
-                  <a:srgbClr val="3B82F6"/>
-                </a:solidFill>
-                <a:latin typeface="Arial"/>
-              </a:defRPr>
-            </a:pPr>
             <a:r>
               <a:t>Posture : Professionnelle + ROI sémantique</a:t>
             </a:r>
@@ -20201,7 +20545,7 @@
 </file>
 
 <file path=ppt/slides/slide6.xml><?xml version="1.0" encoding="utf-8"?>
-<p:sld xmlns:a="http://schemas.openxmlformats.org/drawingml/2006/main" xmlns:p="http://schemas.openxmlformats.org/presentationml/2006/main" xmlns:r="http://schemas.openxmlformats.org/officeDocument/2006/relationships">
+<p:sld xmlns:a="http://schemas.openxmlformats.org/drawingml/2006/main" xmlns:r="http://schemas.openxmlformats.org/officeDocument/2006/relationships" xmlns:p="http://schemas.openxmlformats.org/presentationml/2006/main">
   <p:cSld>
     <p:bg>
       <p:bgPr>
@@ -20217,7 +20561,14 @@
         <p:cNvGrpSpPr/>
         <p:nvPr/>
       </p:nvGrpSpPr>
-      <p:grpSpPr/>
+      <p:grpSpPr>
+        <a:xfrm>
+          <a:off x="0" y="0"/>
+          <a:ext cx="0" cy="0"/>
+          <a:chOff x="0" y="0"/>
+          <a:chExt cx="0" cy="0"/>
+        </a:xfrm>
+      </p:grpSpPr>
       <p:sp>
         <p:nvSpPr>
           <p:cNvPr id="2" name="TextBox 1"/>
@@ -20332,6 +20683,7 @@
           <a:lstStyle/>
           <a:p>
             <a:pPr algn="ctr"/>
+            <a:endParaRPr/>
           </a:p>
         </p:txBody>
       </p:sp>
@@ -20478,17 +20830,6 @@
           </a:p>
           <a:p>
             <a:br/>
-            <a:pPr>
-              <a:spcAft>
-                <a:spcPts val="800"/>
-              </a:spcAft>
-              <a:defRPr sz="1200" b="1">
-                <a:solidFill>
-                  <a:srgbClr val="3B82F6"/>
-                </a:solidFill>
-                <a:latin typeface="Arial"/>
-              </a:defRPr>
-            </a:pPr>
             <a:r>
               <a:t>📞 Script d'Accroche (Gérant décroche)</a:t>
             </a:r>
@@ -20633,6 +20974,7 @@
           <a:lstStyle/>
           <a:p>
             <a:pPr algn="ctr"/>
+            <a:endParaRPr/>
           </a:p>
         </p:txBody>
       </p:sp>
@@ -20883,17 +21225,6 @@
           </a:p>
           <a:p>
             <a:br/>
-            <a:pPr>
-              <a:spcAft>
-                <a:spcPts val="400"/>
-              </a:spcAft>
-              <a:defRPr sz="1000" b="1">
-                <a:solidFill>
-                  <a:srgbClr val="F97316"/>
-                </a:solidFill>
-                <a:latin typeface="Arial"/>
-              </a:defRPr>
-            </a:pPr>
             <a:r>
               <a:t>💡 Si le gérant rappelle suite à un DM envoyé la veille :</a:t>
             </a:r>
@@ -20955,6 +21286,7 @@
           <a:lstStyle/>
           <a:p>
             <a:pPr algn="ctr"/>
+            <a:endParaRPr/>
           </a:p>
         </p:txBody>
       </p:sp>
@@ -20967,7 +21299,7 @@
 </file>
 
 <file path=ppt/slides/slide7.xml><?xml version="1.0" encoding="utf-8"?>
-<p:sld xmlns:a="http://schemas.openxmlformats.org/drawingml/2006/main" xmlns:p="http://schemas.openxmlformats.org/presentationml/2006/main" xmlns:r="http://schemas.openxmlformats.org/officeDocument/2006/relationships">
+<p:sld xmlns:a="http://schemas.openxmlformats.org/drawingml/2006/main" xmlns:r="http://schemas.openxmlformats.org/officeDocument/2006/relationships" xmlns:p="http://schemas.openxmlformats.org/presentationml/2006/main">
   <p:cSld>
     <p:bg>
       <p:bgPr>
@@ -20983,7 +21315,14 @@
         <p:cNvGrpSpPr/>
         <p:nvPr/>
       </p:nvGrpSpPr>
-      <p:grpSpPr/>
+      <p:grpSpPr>
+        <a:xfrm>
+          <a:off x="0" y="0"/>
+          <a:ext cx="0" cy="0"/>
+          <a:chOff x="0" y="0"/>
+          <a:chExt cx="0" cy="0"/>
+        </a:xfrm>
+      </p:grpSpPr>
       <p:sp>
         <p:nvSpPr>
           <p:cNvPr id="2" name="TextBox 1"/>
@@ -21098,6 +21437,7 @@
           <a:lstStyle/>
           <a:p>
             <a:pPr algn="ctr"/>
+            <a:endParaRPr/>
           </a:p>
         </p:txBody>
       </p:sp>
@@ -21208,6 +21548,7 @@
                 <a:spcPts val="200"/>
               </a:spcAft>
             </a:pPr>
+            <a:endParaRPr/>
           </a:p>
           <a:p>
             <a:pPr>
@@ -21263,6 +21604,7 @@
                 <a:spcPts val="200"/>
               </a:spcAft>
             </a:pPr>
+            <a:endParaRPr/>
           </a:p>
           <a:p>
             <a:pPr>
@@ -21372,6 +21714,7 @@
           <a:lstStyle/>
           <a:p>
             <a:pPr algn="ctr"/>
+            <a:endParaRPr/>
           </a:p>
         </p:txBody>
       </p:sp>
@@ -21466,6 +21809,7 @@
                 <a:spcPts val="200"/>
               </a:spcAft>
             </a:pPr>
+            <a:endParaRPr/>
           </a:p>
           <a:p>
             <a:pPr>
@@ -21521,6 +21865,7 @@
                 <a:spcPts val="200"/>
               </a:spcAft>
             </a:pPr>
+            <a:endParaRPr/>
           </a:p>
           <a:p>
             <a:pPr>
@@ -21597,7 +21942,7 @@
 </file>
 
 <file path=ppt/slides/slide8.xml><?xml version="1.0" encoding="utf-8"?>
-<p:sld xmlns:a="http://schemas.openxmlformats.org/drawingml/2006/main" xmlns:p="http://schemas.openxmlformats.org/presentationml/2006/main" xmlns:r="http://schemas.openxmlformats.org/officeDocument/2006/relationships">
+<p:sld xmlns:a="http://schemas.openxmlformats.org/drawingml/2006/main" xmlns:r="http://schemas.openxmlformats.org/officeDocument/2006/relationships" xmlns:p="http://schemas.openxmlformats.org/presentationml/2006/main">
   <p:cSld>
     <p:bg>
       <p:bgPr>
@@ -21613,7 +21958,14 @@
         <p:cNvGrpSpPr/>
         <p:nvPr/>
       </p:nvGrpSpPr>
-      <p:grpSpPr/>
+      <p:grpSpPr>
+        <a:xfrm>
+          <a:off x="0" y="0"/>
+          <a:ext cx="0" cy="0"/>
+          <a:chOff x="0" y="0"/>
+          <a:chExt cx="0" cy="0"/>
+        </a:xfrm>
+      </p:grpSpPr>
       <p:sp>
         <p:nvSpPr>
           <p:cNvPr id="2" name="TextBox 1"/>
@@ -21728,6 +22080,7 @@
           <a:lstStyle/>
           <a:p>
             <a:pPr algn="ctr"/>
+            <a:endParaRPr/>
           </a:p>
         </p:txBody>
       </p:sp>
@@ -21769,7 +22122,7 @@
           </a:fontRef>
         </p:style>
         <p:txBody>
-          <a:bodyPr rtlCol="0" anchor="ctr" wrap="square"/>
+          <a:bodyPr wrap="square" rtlCol="0" anchor="ctr"/>
           <a:lstStyle/>
           <a:p>
             <a:pPr algn="ctr">
@@ -21828,6 +22181,7 @@
           <a:lstStyle/>
           <a:p>
             <a:pPr algn="ctr"/>
+            <a:endParaRPr/>
           </a:p>
         </p:txBody>
       </p:sp>
@@ -21925,6 +22279,7 @@
           <a:lstStyle/>
           <a:p>
             <a:pPr algn="ctr"/>
+            <a:endParaRPr/>
           </a:p>
         </p:txBody>
       </p:sp>
@@ -22006,6 +22361,7 @@
           <a:lstStyle/>
           <a:p>
             <a:pPr algn="ctr"/>
+            <a:endParaRPr/>
           </a:p>
         </p:txBody>
       </p:sp>
@@ -22087,6 +22443,7 @@
           <a:lstStyle/>
           <a:p>
             <a:pPr algn="ctr"/>
+            <a:endParaRPr/>
           </a:p>
         </p:txBody>
       </p:sp>
@@ -22121,7 +22478,24 @@
               </a:defRPr>
             </a:pPr>
             <a:r>
-              <a:t>DM story-réaction : « Propre la pose ! C'est du bi-split Daikin ? »</a:t>
+              <a:rPr dirty="0"/>
+              <a:t>DM story-</a:t>
+            </a:r>
+            <a:r>
+              <a:rPr dirty="0" err="1"/>
+              <a:t>réaction</a:t>
+            </a:r>
+            <a:r>
+              <a:rPr dirty="0"/>
+              <a:t> : « Propre la pose ! </a:t>
+            </a:r>
+            <a:r>
+              <a:rPr dirty="0" err="1"/>
+              <a:t>C'est</a:t>
+            </a:r>
+            <a:r>
+              <a:rPr dirty="0"/>
+              <a:t> du bi-split Daikin ? »</a:t>
             </a:r>
           </a:p>
         </p:txBody>
@@ -22168,6 +22542,7 @@
           <a:lstStyle/>
           <a:p>
             <a:pPr algn="ctr"/>
+            <a:endParaRPr/>
           </a:p>
         </p:txBody>
       </p:sp>
@@ -22249,6 +22624,7 @@
           <a:lstStyle/>
           <a:p>
             <a:pPr algn="ctr"/>
+            <a:endParaRPr/>
           </a:p>
         </p:txBody>
       </p:sp>
@@ -22346,6 +22722,7 @@
           <a:lstStyle/>
           <a:p>
             <a:pPr algn="ctr"/>
+            <a:endParaRPr/>
           </a:p>
         </p:txBody>
       </p:sp>
@@ -22427,6 +22804,7 @@
           <a:lstStyle/>
           <a:p>
             <a:pPr algn="ctr"/>
+            <a:endParaRPr/>
           </a:p>
         </p:txBody>
       </p:sp>
@@ -22508,6 +22886,7 @@
           <a:lstStyle/>
           <a:p>
             <a:pPr algn="ctr"/>
+            <a:endParaRPr/>
           </a:p>
         </p:txBody>
       </p:sp>
@@ -22542,7 +22921,52 @@
               </a:defRPr>
             </a:pPr>
             <a:r>
-              <a:t>Rebond DM si déjà contacté : « Je vous avais envoyé un message hier ».</a:t>
+              <a:rPr dirty="0" err="1"/>
+              <a:t>Rebond</a:t>
+            </a:r>
+            <a:r>
+              <a:rPr dirty="0"/>
+              <a:t> DM </a:t>
+            </a:r>
+            <a:r>
+              <a:rPr dirty="0" err="1"/>
+              <a:t>si</a:t>
+            </a:r>
+            <a:r>
+              <a:rPr dirty="0"/>
+              <a:t> déjà </a:t>
+            </a:r>
+            <a:r>
+              <a:rPr dirty="0" err="1"/>
+              <a:t>contacté</a:t>
+            </a:r>
+            <a:r>
+              <a:rPr dirty="0"/>
+              <a:t> : « Je vous </a:t>
+            </a:r>
+            <a:r>
+              <a:rPr dirty="0" err="1"/>
+              <a:t>avais</a:t>
+            </a:r>
+            <a:r>
+              <a:rPr dirty="0"/>
+              <a:t> </a:t>
+            </a:r>
+            <a:r>
+              <a:rPr dirty="0" err="1"/>
+              <a:t>envoyé</a:t>
+            </a:r>
+            <a:r>
+              <a:rPr dirty="0"/>
+              <a:t> un message </a:t>
+            </a:r>
+            <a:r>
+              <a:rPr dirty="0" err="1"/>
+              <a:t>hier</a:t>
+            </a:r>
+            <a:r>
+              <a:rPr dirty="0"/>
+              <a:t> ».</a:t>
             </a:r>
           </a:p>
         </p:txBody>
@@ -22589,6 +23013,7 @@
           <a:lstStyle/>
           <a:p>
             <a:pPr algn="ctr"/>
+            <a:endParaRPr/>
           </a:p>
         </p:txBody>
       </p:sp>
@@ -22623,7 +23048,40 @@
               </a:defRPr>
             </a:pPr>
             <a:r>
-              <a:t>Si messagerie vocale : Laissez votre prénom + gainable.fr + rappel.</a:t>
+              <a:rPr dirty="0"/>
+              <a:t>Si </a:t>
+            </a:r>
+            <a:r>
+              <a:rPr dirty="0" err="1"/>
+              <a:t>messagerie</a:t>
+            </a:r>
+            <a:r>
+              <a:rPr dirty="0"/>
+              <a:t> </a:t>
+            </a:r>
+            <a:r>
+              <a:rPr dirty="0" err="1"/>
+              <a:t>vocale</a:t>
+            </a:r>
+            <a:r>
+              <a:rPr dirty="0"/>
+              <a:t> : Laissez </a:t>
+            </a:r>
+            <a:r>
+              <a:rPr dirty="0" err="1"/>
+              <a:t>votre</a:t>
+            </a:r>
+            <a:r>
+              <a:rPr dirty="0"/>
+              <a:t> </a:t>
+            </a:r>
+            <a:r>
+              <a:rPr dirty="0" err="1"/>
+              <a:t>prénom</a:t>
+            </a:r>
+            <a:r>
+              <a:rPr dirty="0"/>
+              <a:t> + gainable.fr + rappel.</a:t>
             </a:r>
           </a:p>
         </p:txBody>
@@ -22670,6 +23128,7 @@
           <a:lstStyle/>
           <a:p>
             <a:pPr algn="ctr"/>
+            <a:endParaRPr/>
           </a:p>
         </p:txBody>
       </p:sp>
@@ -22767,6 +23226,7 @@
           <a:lstStyle/>
           <a:p>
             <a:pPr algn="ctr"/>
+            <a:endParaRPr/>
           </a:p>
         </p:txBody>
       </p:sp>
@@ -22848,6 +23308,7 @@
           <a:lstStyle/>
           <a:p>
             <a:pPr algn="ctr"/>
+            <a:endParaRPr/>
           </a:p>
         </p:txBody>
       </p:sp>
@@ -22882,7 +23343,32 @@
               </a:defRPr>
             </a:pPr>
             <a:r>
-              <a:t>« Bonjour [Prénom], je vous ai laissé un message hier. »</a:t>
+              <a:rPr dirty="0"/>
+              <a:t>« Bonjour [</a:t>
+            </a:r>
+            <a:r>
+              <a:rPr dirty="0" err="1"/>
+              <a:t>Prénom</a:t>
+            </a:r>
+            <a:r>
+              <a:rPr dirty="0"/>
+              <a:t>], je vous ai </a:t>
+            </a:r>
+            <a:r>
+              <a:rPr dirty="0" err="1"/>
+              <a:t>laissé</a:t>
+            </a:r>
+            <a:r>
+              <a:rPr dirty="0"/>
+              <a:t> un message </a:t>
+            </a:r>
+            <a:r>
+              <a:rPr dirty="0" err="1"/>
+              <a:t>hier</a:t>
+            </a:r>
+            <a:r>
+              <a:rPr dirty="0"/>
+              <a:t>. »</a:t>
             </a:r>
           </a:p>
         </p:txBody>
@@ -22929,6 +23415,7 @@
           <a:lstStyle/>
           <a:p>
             <a:pPr algn="ctr"/>
+            <a:endParaRPr/>
           </a:p>
         </p:txBody>
       </p:sp>
@@ -22963,7 +23450,48 @@
               </a:defRPr>
             </a:pPr>
             <a:r>
-              <a:t>« Je voulais valider votre intérêt pour l'exclusivité de [Ville] »</a:t>
+              <a:rPr dirty="0"/>
+              <a:t>« Je </a:t>
+            </a:r>
+            <a:r>
+              <a:rPr dirty="0" err="1"/>
+              <a:t>voulais</a:t>
+            </a:r>
+            <a:r>
+              <a:rPr dirty="0"/>
+              <a:t> </a:t>
+            </a:r>
+            <a:r>
+              <a:rPr dirty="0" err="1"/>
+              <a:t>valider</a:t>
+            </a:r>
+            <a:r>
+              <a:rPr dirty="0"/>
+              <a:t> </a:t>
+            </a:r>
+            <a:r>
+              <a:rPr dirty="0" err="1"/>
+              <a:t>votre</a:t>
+            </a:r>
+            <a:r>
+              <a:rPr dirty="0"/>
+              <a:t> </a:t>
+            </a:r>
+            <a:r>
+              <a:rPr dirty="0" err="1"/>
+              <a:t>intérêt</a:t>
+            </a:r>
+            <a:r>
+              <a:rPr dirty="0"/>
+              <a:t> pour </a:t>
+            </a:r>
+            <a:r>
+              <a:rPr dirty="0" err="1"/>
+              <a:t>l'exclusivité</a:t>
+            </a:r>
+            <a:r>
+              <a:rPr dirty="0"/>
+              <a:t> de [Ville] »</a:t>
             </a:r>
           </a:p>
         </p:txBody>
@@ -23010,6 +23538,7 @@
           <a:lstStyle/>
           <a:p>
             <a:pPr algn="ctr"/>
+            <a:endParaRPr/>
           </a:p>
         </p:txBody>
       </p:sp>
@@ -23044,7 +23573,24 @@
               </a:defRPr>
             </a:pPr>
             <a:r>
-              <a:t>« avant de libérer la zone à vos confrères. »</a:t>
+              <a:rPr dirty="0"/>
+              <a:t>« avant de </a:t>
+            </a:r>
+            <a:r>
+              <a:rPr dirty="0" err="1"/>
+              <a:t>libérer</a:t>
+            </a:r>
+            <a:r>
+              <a:rPr dirty="0"/>
+              <a:t> la zone à </a:t>
+            </a:r>
+            <a:r>
+              <a:rPr dirty="0" err="1"/>
+              <a:t>vos</a:t>
+            </a:r>
+            <a:r>
+              <a:rPr dirty="0"/>
+              <a:t> confrères. »</a:t>
             </a:r>
           </a:p>
         </p:txBody>
@@ -23091,6 +23637,7 @@
           <a:lstStyle/>
           <a:p>
             <a:pPr algn="ctr"/>
+            <a:endParaRPr/>
           </a:p>
         </p:txBody>
       </p:sp>
@@ -23188,6 +23735,7 @@
           <a:lstStyle/>
           <a:p>
             <a:pPr algn="ctr"/>
+            <a:endParaRPr/>
           </a:p>
         </p:txBody>
       </p:sp>
@@ -23269,6 +23817,7 @@
           <a:lstStyle/>
           <a:p>
             <a:pPr algn="ctr"/>
+            <a:endParaRPr/>
           </a:p>
         </p:txBody>
       </p:sp>
@@ -23350,6 +23899,7 @@
           <a:lstStyle/>
           <a:p>
             <a:pPr algn="ctr"/>
+            <a:endParaRPr/>
           </a:p>
         </p:txBody>
       </p:sp>
@@ -23384,7 +23934,48 @@
               </a:defRPr>
             </a:pPr>
             <a:r>
-              <a:t>Si accord → envoyez le lien Stripe directement en ligne avec lui.</a:t>
+              <a:rPr dirty="0"/>
+              <a:t>Si accord → </a:t>
+            </a:r>
+            <a:r>
+              <a:rPr dirty="0" err="1"/>
+              <a:t>envoyez</a:t>
+            </a:r>
+            <a:r>
+              <a:rPr dirty="0"/>
+              <a:t> le lien Stripe </a:t>
+            </a:r>
+            <a:r>
+              <a:rPr dirty="0" err="1"/>
+              <a:t>directement</a:t>
+            </a:r>
+            <a:r>
+              <a:rPr dirty="0"/>
+              <a:t> </a:t>
+            </a:r>
+            <a:r>
+              <a:rPr dirty="0" err="1"/>
+              <a:t>en</a:t>
+            </a:r>
+            <a:r>
+              <a:rPr dirty="0"/>
+              <a:t> </a:t>
+            </a:r>
+            <a:r>
+              <a:rPr dirty="0" err="1"/>
+              <a:t>ligne</a:t>
+            </a:r>
+            <a:r>
+              <a:rPr dirty="0"/>
+              <a:t> avec </a:t>
+            </a:r>
+            <a:r>
+              <a:rPr dirty="0" err="1"/>
+              <a:t>lui</a:t>
+            </a:r>
+            <a:r>
+              <a:rPr dirty="0"/>
+              <a:t>.</a:t>
             </a:r>
           </a:p>
         </p:txBody>
@@ -23431,6 +24022,7 @@
           <a:lstStyle/>
           <a:p>
             <a:pPr algn="ctr"/>
+            <a:endParaRPr/>
           </a:p>
         </p:txBody>
       </p:sp>
@@ -23465,7 +24057,32 @@
               </a:defRPr>
             </a:pPr>
             <a:r>
-              <a:t>Si hésitation → code EXCLU10 pour -10% si signature ce jour.</a:t>
+              <a:rPr dirty="0"/>
+              <a:t>Si </a:t>
+            </a:r>
+            <a:r>
+              <a:rPr dirty="0" err="1"/>
+              <a:t>hésitation</a:t>
+            </a:r>
+            <a:r>
+              <a:rPr dirty="0"/>
+              <a:t> → code EXCLU10 pour -10% </a:t>
+            </a:r>
+            <a:r>
+              <a:rPr dirty="0" err="1"/>
+              <a:t>si</a:t>
+            </a:r>
+            <a:r>
+              <a:rPr dirty="0"/>
+              <a:t> signature </a:t>
+            </a:r>
+            <a:r>
+              <a:rPr dirty="0" err="1"/>
+              <a:t>ce</a:t>
+            </a:r>
+            <a:r>
+              <a:rPr dirty="0"/>
+              <a:t> jour.</a:t>
             </a:r>
           </a:p>
         </p:txBody>
@@ -23512,6 +24129,7 @@
           <a:lstStyle/>
           <a:p>
             <a:pPr algn="ctr"/>
+            <a:endParaRPr/>
           </a:p>
         </p:txBody>
       </p:sp>
@@ -23609,6 +24227,7 @@
           <a:lstStyle/>
           <a:p>
             <a:pPr algn="ctr"/>
+            <a:endParaRPr/>
           </a:p>
         </p:txBody>
       </p:sp>
@@ -23690,6 +24309,7 @@
           <a:lstStyle/>
           <a:p>
             <a:pPr algn="ctr"/>
+            <a:endParaRPr/>
           </a:p>
         </p:txBody>
       </p:sp>
@@ -23771,6 +24391,7 @@
           <a:lstStyle/>
           <a:p>
             <a:pPr algn="ctr"/>
+            <a:endParaRPr/>
           </a:p>
         </p:txBody>
       </p:sp>
@@ -23852,6 +24473,7 @@
           <a:lstStyle/>
           <a:p>
             <a:pPr algn="ctr"/>
+            <a:endParaRPr/>
           </a:p>
         </p:txBody>
       </p:sp>
@@ -23900,7 +24522,7 @@
 </file>
 
 <file path=ppt/slides/slide9.xml><?xml version="1.0" encoding="utf-8"?>
-<p:sld xmlns:a="http://schemas.openxmlformats.org/drawingml/2006/main" xmlns:p="http://schemas.openxmlformats.org/presentationml/2006/main" xmlns:r="http://schemas.openxmlformats.org/officeDocument/2006/relationships">
+<p:sld xmlns:a="http://schemas.openxmlformats.org/drawingml/2006/main" xmlns:r="http://schemas.openxmlformats.org/officeDocument/2006/relationships" xmlns:p="http://schemas.openxmlformats.org/presentationml/2006/main">
   <p:cSld>
     <p:bg>
       <p:bgPr>
@@ -23916,7 +24538,14 @@
         <p:cNvGrpSpPr/>
         <p:nvPr/>
       </p:nvGrpSpPr>
-      <p:grpSpPr/>
+      <p:grpSpPr>
+        <a:xfrm>
+          <a:off x="0" y="0"/>
+          <a:ext cx="0" cy="0"/>
+          <a:chOff x="0" y="0"/>
+          <a:chExt cx="0" cy="0"/>
+        </a:xfrm>
+      </p:grpSpPr>
       <p:sp>
         <p:nvSpPr>
           <p:cNvPr id="2" name="TextBox 1"/>
@@ -24031,6 +24660,7 @@
           <a:lstStyle/>
           <a:p>
             <a:pPr algn="ctr"/>
+            <a:endParaRPr/>
           </a:p>
         </p:txBody>
       </p:sp>
@@ -24076,6 +24706,7 @@
           <a:lstStyle/>
           <a:p>
             <a:pPr algn="ctr"/>
+            <a:endParaRPr/>
           </a:p>
         </p:txBody>
       </p:sp>
@@ -24121,6 +24752,7 @@
           <a:lstStyle/>
           <a:p>
             <a:pPr algn="ctr"/>
+            <a:endParaRPr/>
           </a:p>
         </p:txBody>
       </p:sp>
@@ -24301,6 +24933,7 @@
           <a:lstStyle/>
           <a:p>
             <a:pPr algn="ctr"/>
+            <a:endParaRPr/>
           </a:p>
         </p:txBody>
       </p:sp>
@@ -24346,6 +24979,7 @@
           <a:lstStyle/>
           <a:p>
             <a:pPr algn="ctr"/>
+            <a:endParaRPr/>
           </a:p>
         </p:txBody>
       </p:sp>
@@ -24526,6 +25160,7 @@
           <a:lstStyle/>
           <a:p>
             <a:pPr algn="ctr"/>
+            <a:endParaRPr/>
           </a:p>
         </p:txBody>
       </p:sp>
@@ -24571,6 +25206,7 @@
           <a:lstStyle/>
           <a:p>
             <a:pPr algn="ctr"/>
+            <a:endParaRPr/>
           </a:p>
         </p:txBody>
       </p:sp>
@@ -24751,6 +25387,7 @@
           <a:lstStyle/>
           <a:p>
             <a:pPr algn="ctr"/>
+            <a:endParaRPr/>
           </a:p>
         </p:txBody>
       </p:sp>
@@ -24796,6 +25433,7 @@
           <a:lstStyle/>
           <a:p>
             <a:pPr algn="ctr"/>
+            <a:endParaRPr/>
           </a:p>
         </p:txBody>
       </p:sp>

</xml_diff>